<commit_message>
removed and added test. reworked ppt
</commit_message>
<xml_diff>
--- a/PRESENTATION.pptx
+++ b/PRESENTATION.pptx
@@ -5,7 +5,7 @@
     <p:sldMasterId id="2147483648" r:id="rId1"/>
   </p:sldMasterIdLst>
   <p:notesMasterIdLst>
-    <p:notesMasterId r:id="rId16"/>
+    <p:notesMasterId r:id="rId14"/>
   </p:notesMasterIdLst>
   <p:sldIdLst>
     <p:sldId id="256" r:id="rId2"/>
@@ -19,9 +19,7 @@
     <p:sldId id="265" r:id="rId10"/>
     <p:sldId id="266" r:id="rId11"/>
     <p:sldId id="267" r:id="rId12"/>
-    <p:sldId id="268" r:id="rId13"/>
-    <p:sldId id="269" r:id="rId14"/>
-    <p:sldId id="270" r:id="rId15"/>
+    <p:sldId id="269" r:id="rId13"/>
   </p:sldIdLst>
   <p:sldSz cx="9144000" cy="5143500" type="screen16x9"/>
   <p:notesSz cx="5143500" cy="9144000"/>
@@ -557,7 +555,7 @@
           <a:p>
             <a:r>
               <a:rPr lang="en-US" dirty="0"/>
-              <a:t>Analyse: Flaschenhals lokalisiert. Request-Waiting beweist Server-seitige Ursache – typisch single-threaded Node. Konkrete Optimierungen. Ehrlicher localhost-Hinweis.</a:t>
+              <a:t>Warum CI/CD: jede Änderung wird automatisch geprüft. Zwei Pipelines (Build+Unit über Node-Matrix, E2E). Weil keine DB nötig ist, laufen Tests isoliert – schnell, deterministisch, gecached.</a:t>
             </a:r>
           </a:p>
         </p:txBody>
@@ -580,180 +578,6 @@
             <a:fld id="{F7021451-1387-4CA6-816F-3879F97B5CBC}" type="slidenum">
               <a:rPr lang="en-US"/>
               <a:t>12</a:t>
-            </a:fld>
-            <a:endParaRPr lang="en-US"/>
-          </a:p>
-        </p:txBody>
-      </p:sp>
-    </p:spTree>
-    <p:extLst>
-      <p:ext uri="{BB962C8B-B14F-4D97-AF65-F5344CB8AC3E}">
-        <p14:creationId xmlns:p14="http://schemas.microsoft.com/office/powerpoint/2010/main" val="1024086991"/>
-      </p:ext>
-    </p:extLst>
-  </p:cSld>
-  <p:clrMapOvr>
-    <a:masterClrMapping/>
-  </p:clrMapOvr>
-</p:notes>
-</file>
-
-<file path=ppt/notesSlides/notesSlide13.xml><?xml version="1.0" encoding="utf-8"?>
-<p:notes xmlns:a="http://schemas.openxmlformats.org/drawingml/2006/main" xmlns:r="http://schemas.openxmlformats.org/officeDocument/2006/relationships" xmlns:p="http://schemas.openxmlformats.org/presentationml/2006/main">
-  <p:cSld>
-    <p:spTree>
-      <p:nvGrpSpPr>
-        <p:cNvPr id="1" name=""/>
-        <p:cNvGrpSpPr/>
-        <p:nvPr/>
-      </p:nvGrpSpPr>
-      <p:grpSpPr>
-        <a:xfrm>
-          <a:off x="0" y="0"/>
-          <a:ext cx="0" cy="0"/>
-          <a:chOff x="0" y="0"/>
-          <a:chExt cx="0" cy="0"/>
-        </a:xfrm>
-      </p:grpSpPr>
-      <p:sp>
-        <p:nvSpPr>
-          <p:cNvPr id="2" name="Slide Image Placeholder 1"/>
-          <p:cNvSpPr>
-            <a:spLocks noGrp="1" noRot="1" noChangeAspect="1"/>
-          </p:cNvSpPr>
-          <p:nvPr>
-            <p:ph type="sldImg"/>
-          </p:nvPr>
-        </p:nvSpPr>
-        <p:spPr/>
-      </p:sp>
-      <p:sp>
-        <p:nvSpPr>
-          <p:cNvPr id="3" name="Notes Placeholder 2"/>
-          <p:cNvSpPr>
-            <a:spLocks noGrp="1"/>
-          </p:cNvSpPr>
-          <p:nvPr>
-            <p:ph type="body" idx="1"/>
-          </p:nvPr>
-        </p:nvSpPr>
-        <p:spPr/>
-        <p:txBody>
-          <a:bodyPr/>
-          <a:lstStyle/>
-          <a:p>
-            <a:r>
-              <a:rPr lang="en-US" dirty="0"/>
-              <a:t>Warum CI/CD: jede Änderung wird automatisch geprüft. Zwei Pipelines (Build+Unit über Node-Matrix, E2E). Weil keine DB nötig ist, laufen Tests isoliert – schnell, deterministisch, gecached.</a:t>
-            </a:r>
-          </a:p>
-        </p:txBody>
-      </p:sp>
-      <p:sp>
-        <p:nvSpPr>
-          <p:cNvPr id="4" name="Slide Number Placeholder 3"/>
-          <p:cNvSpPr>
-            <a:spLocks noGrp="1"/>
-          </p:cNvSpPr>
-          <p:nvPr>
-            <p:ph type="sldNum" sz="quarter" idx="10"/>
-          </p:nvPr>
-        </p:nvSpPr>
-        <p:spPr/>
-        <p:txBody>
-          <a:bodyPr/>
-          <a:lstStyle/>
-          <a:p>
-            <a:fld id="{F7021451-1387-4CA6-816F-3879F97B5CBC}" type="slidenum">
-              <a:rPr lang="en-US"/>
-              <a:t>13</a:t>
-            </a:fld>
-            <a:endParaRPr lang="en-US"/>
-          </a:p>
-        </p:txBody>
-      </p:sp>
-    </p:spTree>
-    <p:extLst>
-      <p:ext uri="{BB962C8B-B14F-4D97-AF65-F5344CB8AC3E}">
-        <p14:creationId xmlns:p14="http://schemas.microsoft.com/office/powerpoint/2010/main" val="1024086991"/>
-      </p:ext>
-    </p:extLst>
-  </p:cSld>
-  <p:clrMapOvr>
-    <a:masterClrMapping/>
-  </p:clrMapOvr>
-</p:notes>
-</file>
-
-<file path=ppt/notesSlides/notesSlide14.xml><?xml version="1.0" encoding="utf-8"?>
-<p:notes xmlns:a="http://schemas.openxmlformats.org/drawingml/2006/main" xmlns:r="http://schemas.openxmlformats.org/officeDocument/2006/relationships" xmlns:p="http://schemas.openxmlformats.org/presentationml/2006/main">
-  <p:cSld>
-    <p:spTree>
-      <p:nvGrpSpPr>
-        <p:cNvPr id="1" name=""/>
-        <p:cNvGrpSpPr/>
-        <p:nvPr/>
-      </p:nvGrpSpPr>
-      <p:grpSpPr>
-        <a:xfrm>
-          <a:off x="0" y="0"/>
-          <a:ext cx="0" cy="0"/>
-          <a:chOff x="0" y="0"/>
-          <a:chExt cx="0" cy="0"/>
-        </a:xfrm>
-      </p:grpSpPr>
-      <p:sp>
-        <p:nvSpPr>
-          <p:cNvPr id="2" name="Slide Image Placeholder 1"/>
-          <p:cNvSpPr>
-            <a:spLocks noGrp="1" noRot="1" noChangeAspect="1"/>
-          </p:cNvSpPr>
-          <p:nvPr>
-            <p:ph type="sldImg"/>
-          </p:nvPr>
-        </p:nvSpPr>
-        <p:spPr/>
-      </p:sp>
-      <p:sp>
-        <p:nvSpPr>
-          <p:cNvPr id="3" name="Notes Placeholder 2"/>
-          <p:cNvSpPr>
-            <a:spLocks noGrp="1"/>
-          </p:cNvSpPr>
-          <p:nvPr>
-            <p:ph type="body" idx="1"/>
-          </p:nvPr>
-        </p:nvSpPr>
-        <p:spPr/>
-        <p:txBody>
-          <a:bodyPr/>
-          <a:lstStyle/>
-          <a:p>
-            <a:r>
-              <a:rPr lang="en-US" dirty="0"/>
-              <a:t>Zusammenfassen: jede Testebene adressiert ein eigenes Risiko. Auswahl architektur-getrieben, bewusst auch Fehlerfaelle, Schwaechen dokumentiert. Kernzahlen: solide bis ~500 Nutzer, Saettigung ~2000 req/s. Offen fuer Fragen.</a:t>
-            </a:r>
-          </a:p>
-        </p:txBody>
-      </p:sp>
-      <p:sp>
-        <p:nvSpPr>
-          <p:cNvPr id="4" name="Slide Number Placeholder 3"/>
-          <p:cNvSpPr>
-            <a:spLocks noGrp="1"/>
-          </p:cNvSpPr>
-          <p:nvPr>
-            <p:ph type="sldNum" sz="quarter" idx="10"/>
-          </p:nvPr>
-        </p:nvSpPr>
-        <p:spPr/>
-        <p:txBody>
-          <a:bodyPr/>
-          <a:lstStyle/>
-          <a:p>
-            <a:fld id="{F7021451-1387-4CA6-816F-3879F97B5CBC}" type="slidenum">
-              <a:rPr lang="en-US"/>
-              <a:t>14</a:t>
             </a:fld>
             <a:endParaRPr lang="en-US"/>
           </a:p>
@@ -1807,14 +1631,14 @@
       </p:grpSpPr>
       <p:sp>
         <p:nvSpPr>
-          <p:cNvPr id="2" name="Text 0"/>
-          <p:cNvSpPr/>
-          <p:nvPr/>
-        </p:nvSpPr>
-        <p:spPr>
-          <a:xfrm>
-            <a:off x="502920" y="1051560"/>
-            <a:ext cx="5486400" cy="310896"/>
+          <p:cNvPr id="3" name="Text 1"/>
+          <p:cNvSpPr/>
+          <p:nvPr/>
+        </p:nvSpPr>
+        <p:spPr>
+          <a:xfrm>
+            <a:off x="502920" y="1508760"/>
+            <a:ext cx="8229600" cy="365760"/>
           </a:xfrm>
           <a:prstGeom prst="rect">
             <a:avLst/>
@@ -1830,53 +1654,14 @@
               <a:buNone/>
             </a:pPr>
             <a:r>
-              <a:rPr lang="en-US" sz="1300" dirty="0">
-                <a:solidFill>
-                  <a:srgbClr val="06B6D4"/>
+              <a:rPr lang="en-US" sz="1300" kern="0" spc="300" dirty="0">
+                <a:solidFill>
+                  <a:srgbClr val="C7D2DD"/>
                 </a:solidFill>
                 <a:latin typeface="Courier New" pitchFamily="34" charset="0"/>
                 <a:ea typeface="Courier New" pitchFamily="34" charset="-122"/>
                 <a:cs typeface="Courier New" pitchFamily="34" charset="-120"/>
               </a:rPr>
-              <a:t>$ npm test  &amp;&amp;  k6 run</a:t>
-            </a:r>
-            <a:endParaRPr lang="en-US" sz="1300" dirty="0"/>
-          </a:p>
-        </p:txBody>
-      </p:sp>
-      <p:sp>
-        <p:nvSpPr>
-          <p:cNvPr id="3" name="Text 1"/>
-          <p:cNvSpPr/>
-          <p:nvPr/>
-        </p:nvSpPr>
-        <p:spPr>
-          <a:xfrm>
-            <a:off x="502920" y="1508760"/>
-            <a:ext cx="8229600" cy="365760"/>
-          </a:xfrm>
-          <a:prstGeom prst="rect">
-            <a:avLst/>
-          </a:prstGeom>
-          <a:noFill/>
-          <a:ln/>
-        </p:spPr>
-        <p:txBody>
-          <a:bodyPr wrap="square" lIns="0" tIns="0" rIns="0" bIns="0" rtlCol="0" anchor="ctr"/>
-          <a:lstStyle/>
-          <a:p>
-            <a:pPr marL="0" indent="0">
-              <a:buNone/>
-            </a:pPr>
-            <a:r>
-              <a:rPr lang="en-US" sz="1300" kern="0" spc="300" dirty="0">
-                <a:solidFill>
-                  <a:srgbClr val="C7D2DD"/>
-                </a:solidFill>
-                <a:latin typeface="Courier New" pitchFamily="34" charset="0"/>
-                <a:ea typeface="Courier New" pitchFamily="34" charset="-122"/>
-                <a:cs typeface="Courier New" pitchFamily="34" charset="-120"/>
-              </a:rPr>
               <a:t>Web Application Testing</a:t>
             </a:r>
             <a:endParaRPr lang="en-US" sz="1300" dirty="0"/>
@@ -1946,17 +1731,6 @@
             <a:pPr marL="0" indent="0">
               <a:buNone/>
             </a:pPr>
-            <a:r>
-              <a:rPr lang="en-US" sz="1600" dirty="0">
-                <a:solidFill>
-                  <a:srgbClr val="C7D2DD"/>
-                </a:solidFill>
-                <a:latin typeface="Calibri" pitchFamily="34" charset="0"/>
-                <a:ea typeface="Calibri" pitchFamily="34" charset="-122"/>
-                <a:cs typeface="Calibri" pitchFamily="34" charset="-120"/>
-              </a:rPr>
-              <a:t>Eine mehrschichtige Teststrategie: was wurde warum und wie getestet?</a:t>
-            </a:r>
             <a:endParaRPr lang="en-US" sz="1600" dirty="0"/>
           </a:p>
         </p:txBody>
@@ -2889,7 +2663,7 @@
         </p:blipFill>
         <p:spPr>
           <a:xfrm>
-            <a:off x="502920" y="1188720"/>
+            <a:off x="1365442" y="1179576"/>
             <a:ext cx="6024366" cy="1143000"/>
           </a:xfrm>
           <a:prstGeom prst="rect">
@@ -3410,801 +3184,6 @@
 </file>
 
 <file path=ppt/slides/slide12.xml><?xml version="1.0" encoding="utf-8"?>
-<p:sld xmlns:a="http://schemas.openxmlformats.org/drawingml/2006/main" xmlns:r="http://schemas.openxmlformats.org/officeDocument/2006/relationships" xmlns:p="http://schemas.openxmlformats.org/presentationml/2006/main">
-  <p:cSld name="Slide 13">
-    <p:bg>
-      <p:bgPr>
-        <a:solidFill>
-          <a:srgbClr val="FFFFFF"/>
-        </a:solidFill>
-        <a:effectLst/>
-      </p:bgPr>
-    </p:bg>
-    <p:spTree>
-      <p:nvGrpSpPr>
-        <p:cNvPr id="1" name=""/>
-        <p:cNvGrpSpPr/>
-        <p:nvPr/>
-      </p:nvGrpSpPr>
-      <p:grpSpPr>
-        <a:xfrm>
-          <a:off x="0" y="0"/>
-          <a:ext cx="0" cy="0"/>
-          <a:chOff x="0" y="0"/>
-          <a:chExt cx="0" cy="0"/>
-        </a:xfrm>
-      </p:grpSpPr>
-      <p:sp>
-        <p:nvSpPr>
-          <p:cNvPr id="2" name="Text 0"/>
-          <p:cNvSpPr/>
-          <p:nvPr/>
-        </p:nvSpPr>
-        <p:spPr>
-          <a:xfrm>
-            <a:off x="502920" y="310896"/>
-            <a:ext cx="8138160" cy="256032"/>
-          </a:xfrm>
-          <a:prstGeom prst="rect">
-            <a:avLst/>
-          </a:prstGeom>
-          <a:noFill/>
-          <a:ln/>
-        </p:spPr>
-        <p:txBody>
-          <a:bodyPr wrap="square" lIns="0" tIns="0" rIns="0" bIns="0" rtlCol="0" anchor="ctr"/>
-          <a:lstStyle/>
-          <a:p>
-            <a:pPr marL="0" indent="0">
-              <a:buNone/>
-            </a:pPr>
-            <a:r>
-              <a:rPr lang="en-US" sz="1100" b="1" kern="0" spc="200" dirty="0">
-                <a:solidFill>
-                  <a:srgbClr val="0E7490"/>
-                </a:solidFill>
-                <a:latin typeface="Courier New" pitchFamily="34" charset="0"/>
-                <a:ea typeface="Courier New" pitchFamily="34" charset="-122"/>
-                <a:cs typeface="Courier New" pitchFamily="34" charset="-120"/>
-              </a:rPr>
-              <a:t>ANALYSE</a:t>
-            </a:r>
-            <a:endParaRPr lang="en-US" sz="1100" dirty="0"/>
-          </a:p>
-        </p:txBody>
-      </p:sp>
-      <p:sp>
-        <p:nvSpPr>
-          <p:cNvPr id="3" name="Text 1"/>
-          <p:cNvSpPr/>
-          <p:nvPr/>
-        </p:nvSpPr>
-        <p:spPr>
-          <a:xfrm>
-            <a:off x="502920" y="548640"/>
-            <a:ext cx="8138160" cy="566928"/>
-          </a:xfrm>
-          <a:prstGeom prst="rect">
-            <a:avLst/>
-          </a:prstGeom>
-          <a:noFill/>
-          <a:ln/>
-        </p:spPr>
-        <p:txBody>
-          <a:bodyPr wrap="square" lIns="0" tIns="0" rIns="0" bIns="0" rtlCol="0" anchor="ctr"/>
-          <a:lstStyle/>
-          <a:p>
-            <a:pPr marL="0" indent="0">
-              <a:buNone/>
-            </a:pPr>
-            <a:r>
-              <a:rPr lang="en-US" sz="2700" b="1" dirty="0">
-                <a:solidFill>
-                  <a:srgbClr val="12181F"/>
-                </a:solidFill>
-                <a:latin typeface="Calibri" pitchFamily="34" charset="0"/>
-                <a:ea typeface="Calibri" pitchFamily="34" charset="-122"/>
-                <a:cs typeface="Calibri" pitchFamily="34" charset="-120"/>
-              </a:rPr>
-              <a:t>Flaschenhals &amp; Optimierung</a:t>
-            </a:r>
-            <a:endParaRPr lang="en-US" sz="2700" dirty="0"/>
-          </a:p>
-        </p:txBody>
-      </p:sp>
-      <p:sp>
-        <p:nvSpPr>
-          <p:cNvPr id="4" name="Shape 2"/>
-          <p:cNvSpPr/>
-          <p:nvPr/>
-        </p:nvSpPr>
-        <p:spPr>
-          <a:xfrm>
-            <a:off x="8494776" y="384048"/>
-            <a:ext cx="146304" cy="146304"/>
-          </a:xfrm>
-          <a:prstGeom prst="ellipse">
-            <a:avLst/>
-          </a:prstGeom>
-          <a:solidFill>
-            <a:srgbClr val="06B6D4"/>
-          </a:solidFill>
-          <a:ln/>
-        </p:spPr>
-        <p:txBody>
-          <a:bodyPr/>
-          <a:lstStyle/>
-          <a:p>
-            <a:endParaRPr lang="de-AT"/>
-          </a:p>
-        </p:txBody>
-      </p:sp>
-      <p:sp>
-        <p:nvSpPr>
-          <p:cNvPr id="5" name="Shape 3"/>
-          <p:cNvSpPr/>
-          <p:nvPr/>
-        </p:nvSpPr>
-        <p:spPr>
-          <a:xfrm>
-            <a:off x="502920" y="1325880"/>
-            <a:ext cx="4114800" cy="2788920"/>
-          </a:xfrm>
-          <a:prstGeom prst="roundRect">
-            <a:avLst>
-              <a:gd name="adj" fmla="val 2951"/>
-            </a:avLst>
-          </a:prstGeom>
-          <a:solidFill>
-            <a:srgbClr val="F2F5F8"/>
-          </a:solidFill>
-          <a:ln w="12700">
-            <a:solidFill>
-              <a:srgbClr val="E2E8F0"/>
-            </a:solidFill>
-            <a:prstDash val="solid"/>
-          </a:ln>
-        </p:spPr>
-        <p:txBody>
-          <a:bodyPr/>
-          <a:lstStyle/>
-          <a:p>
-            <a:endParaRPr lang="de-AT"/>
-          </a:p>
-        </p:txBody>
-      </p:sp>
-      <p:sp>
-        <p:nvSpPr>
-          <p:cNvPr id="6" name="Text 4"/>
-          <p:cNvSpPr/>
-          <p:nvPr/>
-        </p:nvSpPr>
-        <p:spPr>
-          <a:xfrm>
-            <a:off x="731520" y="1463040"/>
-            <a:ext cx="3657600" cy="365760"/>
-          </a:xfrm>
-          <a:prstGeom prst="rect">
-            <a:avLst/>
-          </a:prstGeom>
-          <a:noFill/>
-          <a:ln/>
-        </p:spPr>
-        <p:txBody>
-          <a:bodyPr wrap="square" lIns="0" tIns="0" rIns="0" bIns="0" rtlCol="0" anchor="ctr"/>
-          <a:lstStyle/>
-          <a:p>
-            <a:pPr marL="0" indent="0">
-              <a:buNone/>
-            </a:pPr>
-            <a:r>
-              <a:rPr lang="en-US" sz="1550" b="1" dirty="0">
-                <a:solidFill>
-                  <a:srgbClr val="12181F"/>
-                </a:solidFill>
-                <a:latin typeface="Calibri" pitchFamily="34" charset="0"/>
-                <a:ea typeface="Calibri" pitchFamily="34" charset="-122"/>
-                <a:cs typeface="Calibri" pitchFamily="34" charset="-120"/>
-              </a:rPr>
-              <a:t>Wo steckt der Flaschenhals?</a:t>
-            </a:r>
-            <a:endParaRPr lang="en-US" sz="1550" dirty="0"/>
-          </a:p>
-        </p:txBody>
-      </p:sp>
-      <p:sp>
-        <p:nvSpPr>
-          <p:cNvPr id="7" name="Text 5"/>
-          <p:cNvSpPr/>
-          <p:nvPr/>
-        </p:nvSpPr>
-        <p:spPr>
-          <a:xfrm>
-            <a:off x="731520" y="1874520"/>
-            <a:ext cx="3657600" cy="2148840"/>
-          </a:xfrm>
-          <a:prstGeom prst="rect">
-            <a:avLst/>
-          </a:prstGeom>
-          <a:noFill/>
-          <a:ln/>
-        </p:spPr>
-        <p:txBody>
-          <a:bodyPr wrap="square" lIns="0" tIns="0" rIns="0" bIns="0" rtlCol="0" anchor="ctr"/>
-          <a:lstStyle/>
-          <a:p>
-            <a:pPr marL="0" indent="0">
-              <a:lnSpc>
-                <a:spcPct val="108000"/>
-              </a:lnSpc>
-              <a:buNone/>
-            </a:pPr>
-            <a:r>
-              <a:rPr lang="en-US" sz="1150" dirty="0">
-                <a:solidFill>
-                  <a:srgbClr val="5B6675"/>
-                </a:solidFill>
-                <a:latin typeface="Calibri" pitchFamily="34" charset="0"/>
-                <a:ea typeface="Calibri" pitchFamily="34" charset="-122"/>
-                <a:cs typeface="Calibri" pitchFamily="34" charset="-120"/>
-              </a:rPr>
-              <a:t>Request-Phasen aufgeschlüsselt:
-</a:t>
-            </a:r>
-            <a:endParaRPr lang="en-US" sz="1200" dirty="0"/>
-          </a:p>
-          <a:p>
-            <a:pPr marL="0" indent="0">
-              <a:lnSpc>
-                <a:spcPct val="108000"/>
-              </a:lnSpc>
-              <a:buNone/>
-            </a:pPr>
-            <a:r>
-              <a:rPr lang="en-US" sz="1200" b="1" dirty="0">
-                <a:solidFill>
-                  <a:srgbClr val="12181F"/>
-                </a:solidFill>
-                <a:latin typeface="Calibri" pitchFamily="34" charset="0"/>
-                <a:ea typeface="Calibri" pitchFamily="34" charset="-122"/>
-                <a:cs typeface="Calibri" pitchFamily="34" charset="-120"/>
-              </a:rPr>
-              <a:t>• Waiting (Server)  </a:t>
-            </a:r>
-            <a:r>
-              <a:rPr lang="en-US" sz="1200" b="1" dirty="0">
-                <a:solidFill>
-                  <a:srgbClr val="E0524B"/>
-                </a:solidFill>
-                <a:latin typeface="Calibri" pitchFamily="34" charset="0"/>
-                <a:ea typeface="Calibri" pitchFamily="34" charset="-122"/>
-                <a:cs typeface="Calibri" pitchFamily="34" charset="-120"/>
-              </a:rPr>
-              <a:t>→ 1,5–2 s
-</a:t>
-            </a:r>
-            <a:r>
-              <a:rPr lang="en-US" sz="1200" dirty="0">
-                <a:solidFill>
-                  <a:srgbClr val="12181F"/>
-                </a:solidFill>
-                <a:latin typeface="Calibri" pitchFamily="34" charset="0"/>
-                <a:ea typeface="Calibri" pitchFamily="34" charset="-122"/>
-                <a:cs typeface="Calibri" pitchFamily="34" charset="-120"/>
-              </a:rPr>
-              <a:t>• Sending (Netzwerk)  </a:t>
-            </a:r>
-            <a:r>
-              <a:rPr lang="en-US" sz="1200" dirty="0">
-                <a:solidFill>
-                  <a:srgbClr val="16A34A"/>
-                </a:solidFill>
-                <a:latin typeface="Calibri" pitchFamily="34" charset="0"/>
-                <a:ea typeface="Calibri" pitchFamily="34" charset="-122"/>
-                <a:cs typeface="Calibri" pitchFamily="34" charset="-120"/>
-              </a:rPr>
-              <a:t>→ µs
-</a:t>
-            </a:r>
-            <a:r>
-              <a:rPr lang="en-US" sz="1200" dirty="0">
-                <a:solidFill>
-                  <a:srgbClr val="12181F"/>
-                </a:solidFill>
-                <a:latin typeface="Calibri" pitchFamily="34" charset="0"/>
-                <a:ea typeface="Calibri" pitchFamily="34" charset="-122"/>
-                <a:cs typeface="Calibri" pitchFamily="34" charset="-120"/>
-              </a:rPr>
-              <a:t>• TLS  </a:t>
-            </a:r>
-            <a:r>
-              <a:rPr lang="en-US" sz="1200" dirty="0">
-                <a:solidFill>
-                  <a:srgbClr val="16A34A"/>
-                </a:solidFill>
-                <a:latin typeface="Calibri" pitchFamily="34" charset="0"/>
-                <a:ea typeface="Calibri" pitchFamily="34" charset="-122"/>
-                <a:cs typeface="Calibri" pitchFamily="34" charset="-120"/>
-              </a:rPr>
-              <a:t>→ 0 (reines HTTP)
-</a:t>
-            </a:r>
-            <a:r>
-              <a:rPr lang="en-US" sz="1150" dirty="0">
-                <a:solidFill>
-                  <a:srgbClr val="12181F"/>
-                </a:solidFill>
-                <a:latin typeface="Calibri" pitchFamily="34" charset="0"/>
-                <a:ea typeface="Calibri" pitchFamily="34" charset="-122"/>
-                <a:cs typeface="Calibri" pitchFamily="34" charset="-120"/>
-              </a:rPr>
-              <a:t>Die Zeit verstreicht im Server selbst – nicht im Netzwerk. Ursache: Node.js ist single-threaded; der Event-Loop sättigt bei ~2.000 req/s.</a:t>
-            </a:r>
-            <a:endParaRPr lang="en-US" sz="1200" dirty="0"/>
-          </a:p>
-        </p:txBody>
-      </p:sp>
-      <p:sp>
-        <p:nvSpPr>
-          <p:cNvPr id="8" name="Shape 6"/>
-          <p:cNvSpPr/>
-          <p:nvPr/>
-        </p:nvSpPr>
-        <p:spPr>
-          <a:xfrm>
-            <a:off x="4937760" y="1417320"/>
-            <a:ext cx="310896" cy="310896"/>
-          </a:xfrm>
-          <a:prstGeom prst="ellipse">
-            <a:avLst/>
-          </a:prstGeom>
-          <a:solidFill>
-            <a:srgbClr val="0E7490"/>
-          </a:solidFill>
-          <a:ln/>
-        </p:spPr>
-        <p:txBody>
-          <a:bodyPr/>
-          <a:lstStyle/>
-          <a:p>
-            <a:endParaRPr lang="de-AT"/>
-          </a:p>
-        </p:txBody>
-      </p:sp>
-      <p:sp>
-        <p:nvSpPr>
-          <p:cNvPr id="9" name="Text 7"/>
-          <p:cNvSpPr/>
-          <p:nvPr/>
-        </p:nvSpPr>
-        <p:spPr>
-          <a:xfrm>
-            <a:off x="4937760" y="1417320"/>
-            <a:ext cx="310896" cy="310896"/>
-          </a:xfrm>
-          <a:prstGeom prst="rect">
-            <a:avLst/>
-          </a:prstGeom>
-          <a:noFill/>
-          <a:ln/>
-        </p:spPr>
-        <p:txBody>
-          <a:bodyPr wrap="square" lIns="0" tIns="0" rIns="0" bIns="0" rtlCol="0" anchor="ctr"/>
-          <a:lstStyle/>
-          <a:p>
-            <a:pPr marL="0" indent="0" algn="ctr">
-              <a:buNone/>
-            </a:pPr>
-            <a:r>
-              <a:rPr lang="en-US" sz="1300" b="1" dirty="0">
-                <a:solidFill>
-                  <a:srgbClr val="FFFFFF"/>
-                </a:solidFill>
-                <a:latin typeface="Courier New" pitchFamily="34" charset="0"/>
-                <a:ea typeface="Courier New" pitchFamily="34" charset="-122"/>
-                <a:cs typeface="Courier New" pitchFamily="34" charset="-120"/>
-              </a:rPr>
-              <a:t>1</a:t>
-            </a:r>
-            <a:endParaRPr lang="en-US" sz="1300" dirty="0"/>
-          </a:p>
-        </p:txBody>
-      </p:sp>
-      <p:sp>
-        <p:nvSpPr>
-          <p:cNvPr id="10" name="Text 8"/>
-          <p:cNvSpPr/>
-          <p:nvPr/>
-        </p:nvSpPr>
-        <p:spPr>
-          <a:xfrm>
-            <a:off x="5394960" y="1371600"/>
-            <a:ext cx="3291840" cy="822960"/>
-          </a:xfrm>
-          <a:prstGeom prst="rect">
-            <a:avLst/>
-          </a:prstGeom>
-          <a:noFill/>
-          <a:ln/>
-        </p:spPr>
-        <p:txBody>
-          <a:bodyPr wrap="square" lIns="0" tIns="0" rIns="0" bIns="0" rtlCol="0" anchor="ctr"/>
-          <a:lstStyle/>
-          <a:p>
-            <a:pPr marL="0" indent="0">
-              <a:lnSpc>
-                <a:spcPct val="105000"/>
-              </a:lnSpc>
-              <a:buNone/>
-            </a:pPr>
-            <a:r>
-              <a:rPr lang="en-US" sz="1400" b="1" dirty="0">
-                <a:solidFill>
-                  <a:srgbClr val="12181F"/>
-                </a:solidFill>
-                <a:latin typeface="Calibri" pitchFamily="34" charset="0"/>
-                <a:ea typeface="Calibri" pitchFamily="34" charset="-122"/>
-                <a:cs typeface="Calibri" pitchFamily="34" charset="-120"/>
-              </a:rPr>
-              <a:t>Horizontal skalieren
-</a:t>
-            </a:r>
-            <a:r>
-              <a:rPr lang="en-US" sz="1150" dirty="0">
-                <a:solidFill>
-                  <a:srgbClr val="5B6675"/>
-                </a:solidFill>
-                <a:latin typeface="Calibri" pitchFamily="34" charset="0"/>
-                <a:ea typeface="Calibri" pitchFamily="34" charset="-122"/>
-                <a:cs typeface="Calibri" pitchFamily="34" charset="-120"/>
-              </a:rPr>
-              <a:t>Node Cluster / PM2 über alle CPU-Kerne, mehrere Instanzen hinter Load Balancer</a:t>
-            </a:r>
-            <a:endParaRPr lang="en-US" sz="1400" dirty="0"/>
-          </a:p>
-        </p:txBody>
-      </p:sp>
-      <p:sp>
-        <p:nvSpPr>
-          <p:cNvPr id="11" name="Shape 9"/>
-          <p:cNvSpPr/>
-          <p:nvPr/>
-        </p:nvSpPr>
-        <p:spPr>
-          <a:xfrm>
-            <a:off x="4937760" y="2331720"/>
-            <a:ext cx="310896" cy="310896"/>
-          </a:xfrm>
-          <a:prstGeom prst="ellipse">
-            <a:avLst/>
-          </a:prstGeom>
-          <a:solidFill>
-            <a:srgbClr val="0E7490"/>
-          </a:solidFill>
-          <a:ln/>
-        </p:spPr>
-        <p:txBody>
-          <a:bodyPr/>
-          <a:lstStyle/>
-          <a:p>
-            <a:endParaRPr lang="de-AT"/>
-          </a:p>
-        </p:txBody>
-      </p:sp>
-      <p:sp>
-        <p:nvSpPr>
-          <p:cNvPr id="12" name="Text 10"/>
-          <p:cNvSpPr/>
-          <p:nvPr/>
-        </p:nvSpPr>
-        <p:spPr>
-          <a:xfrm>
-            <a:off x="4937760" y="2331720"/>
-            <a:ext cx="310896" cy="310896"/>
-          </a:xfrm>
-          <a:prstGeom prst="rect">
-            <a:avLst/>
-          </a:prstGeom>
-          <a:noFill/>
-          <a:ln/>
-        </p:spPr>
-        <p:txBody>
-          <a:bodyPr wrap="square" lIns="0" tIns="0" rIns="0" bIns="0" rtlCol="0" anchor="ctr"/>
-          <a:lstStyle/>
-          <a:p>
-            <a:pPr marL="0" indent="0" algn="ctr">
-              <a:buNone/>
-            </a:pPr>
-            <a:r>
-              <a:rPr lang="en-US" sz="1300" b="1" dirty="0">
-                <a:solidFill>
-                  <a:srgbClr val="FFFFFF"/>
-                </a:solidFill>
-                <a:latin typeface="Courier New" pitchFamily="34" charset="0"/>
-                <a:ea typeface="Courier New" pitchFamily="34" charset="-122"/>
-                <a:cs typeface="Courier New" pitchFamily="34" charset="-120"/>
-              </a:rPr>
-              <a:t>2</a:t>
-            </a:r>
-            <a:endParaRPr lang="en-US" sz="1300" dirty="0"/>
-          </a:p>
-        </p:txBody>
-      </p:sp>
-      <p:sp>
-        <p:nvSpPr>
-          <p:cNvPr id="13" name="Text 11"/>
-          <p:cNvSpPr/>
-          <p:nvPr/>
-        </p:nvSpPr>
-        <p:spPr>
-          <a:xfrm>
-            <a:off x="5394960" y="2286000"/>
-            <a:ext cx="3291840" cy="822960"/>
-          </a:xfrm>
-          <a:prstGeom prst="rect">
-            <a:avLst/>
-          </a:prstGeom>
-          <a:noFill/>
-          <a:ln/>
-        </p:spPr>
-        <p:txBody>
-          <a:bodyPr wrap="square" lIns="0" tIns="0" rIns="0" bIns="0" rtlCol="0" anchor="ctr"/>
-          <a:lstStyle/>
-          <a:p>
-            <a:pPr marL="0" indent="0">
-              <a:lnSpc>
-                <a:spcPct val="105000"/>
-              </a:lnSpc>
-              <a:buNone/>
-            </a:pPr>
-            <a:r>
-              <a:rPr lang="en-US" sz="1400" b="1" dirty="0">
-                <a:solidFill>
-                  <a:srgbClr val="12181F"/>
-                </a:solidFill>
-                <a:latin typeface="Calibri" pitchFamily="34" charset="0"/>
-                <a:ea typeface="Calibri" pitchFamily="34" charset="-122"/>
-                <a:cs typeface="Calibri" pitchFamily="34" charset="-120"/>
-              </a:rPr>
-              <a:t>Caching
-</a:t>
-            </a:r>
-            <a:r>
-              <a:rPr lang="en-US" sz="1150" dirty="0">
-                <a:solidFill>
-                  <a:srgbClr val="5B6675"/>
-                </a:solidFill>
-                <a:latin typeface="Calibri" pitchFamily="34" charset="0"/>
-                <a:ea typeface="Calibri" pitchFamily="34" charset="-122"/>
-                <a:cs typeface="Calibri" pitchFamily="34" charset="-120"/>
-              </a:rPr>
-              <a:t>Statische Produktdaten zwischenspeichern</a:t>
-            </a:r>
-            <a:endParaRPr lang="en-US" sz="1400" dirty="0"/>
-          </a:p>
-        </p:txBody>
-      </p:sp>
-      <p:sp>
-        <p:nvSpPr>
-          <p:cNvPr id="14" name="Shape 12"/>
-          <p:cNvSpPr/>
-          <p:nvPr/>
-        </p:nvSpPr>
-        <p:spPr>
-          <a:xfrm>
-            <a:off x="4937760" y="3246120"/>
-            <a:ext cx="310896" cy="310896"/>
-          </a:xfrm>
-          <a:prstGeom prst="ellipse">
-            <a:avLst/>
-          </a:prstGeom>
-          <a:solidFill>
-            <a:srgbClr val="0E7490"/>
-          </a:solidFill>
-          <a:ln/>
-        </p:spPr>
-        <p:txBody>
-          <a:bodyPr/>
-          <a:lstStyle/>
-          <a:p>
-            <a:endParaRPr lang="de-AT"/>
-          </a:p>
-        </p:txBody>
-      </p:sp>
-      <p:sp>
-        <p:nvSpPr>
-          <p:cNvPr id="15" name="Text 13"/>
-          <p:cNvSpPr/>
-          <p:nvPr/>
-        </p:nvSpPr>
-        <p:spPr>
-          <a:xfrm>
-            <a:off x="4937760" y="3246120"/>
-            <a:ext cx="310896" cy="310896"/>
-          </a:xfrm>
-          <a:prstGeom prst="rect">
-            <a:avLst/>
-          </a:prstGeom>
-          <a:noFill/>
-          <a:ln/>
-        </p:spPr>
-        <p:txBody>
-          <a:bodyPr wrap="square" lIns="0" tIns="0" rIns="0" bIns="0" rtlCol="0" anchor="ctr"/>
-          <a:lstStyle/>
-          <a:p>
-            <a:pPr marL="0" indent="0" algn="ctr">
-              <a:buNone/>
-            </a:pPr>
-            <a:r>
-              <a:rPr lang="en-US" sz="1300" b="1" dirty="0">
-                <a:solidFill>
-                  <a:srgbClr val="FFFFFF"/>
-                </a:solidFill>
-                <a:latin typeface="Courier New" pitchFamily="34" charset="0"/>
-                <a:ea typeface="Courier New" pitchFamily="34" charset="-122"/>
-                <a:cs typeface="Courier New" pitchFamily="34" charset="-120"/>
-              </a:rPr>
-              <a:t>3</a:t>
-            </a:r>
-            <a:endParaRPr lang="en-US" sz="1300" dirty="0"/>
-          </a:p>
-        </p:txBody>
-      </p:sp>
-      <p:sp>
-        <p:nvSpPr>
-          <p:cNvPr id="16" name="Text 14"/>
-          <p:cNvSpPr/>
-          <p:nvPr/>
-        </p:nvSpPr>
-        <p:spPr>
-          <a:xfrm>
-            <a:off x="5394960" y="3200400"/>
-            <a:ext cx="3291840" cy="822960"/>
-          </a:xfrm>
-          <a:prstGeom prst="rect">
-            <a:avLst/>
-          </a:prstGeom>
-          <a:noFill/>
-          <a:ln/>
-        </p:spPr>
-        <p:txBody>
-          <a:bodyPr wrap="square" lIns="0" tIns="0" rIns="0" bIns="0" rtlCol="0" anchor="ctr"/>
-          <a:lstStyle/>
-          <a:p>
-            <a:pPr marL="0" indent="0">
-              <a:lnSpc>
-                <a:spcPct val="105000"/>
-              </a:lnSpc>
-              <a:buNone/>
-            </a:pPr>
-            <a:r>
-              <a:rPr lang="en-US" sz="1400" b="1" dirty="0">
-                <a:solidFill>
-                  <a:srgbClr val="12181F"/>
-                </a:solidFill>
-                <a:latin typeface="Calibri" pitchFamily="34" charset="0"/>
-                <a:ea typeface="Calibri" pitchFamily="34" charset="-122"/>
-                <a:cs typeface="Calibri" pitchFamily="34" charset="-120"/>
-              </a:rPr>
-              <a:t>Connection-Tuning
-</a:t>
-            </a:r>
-            <a:r>
-              <a:rPr lang="en-US" sz="1150" dirty="0">
-                <a:solidFill>
-                  <a:srgbClr val="5B6675"/>
-                </a:solidFill>
-                <a:latin typeface="Calibri" pitchFamily="34" charset="0"/>
-                <a:ea typeface="Calibri" pitchFamily="34" charset="-122"/>
-                <a:cs typeface="Calibri" pitchFamily="34" charset="-120"/>
-              </a:rPr>
-              <a:t>Keep-alive &amp; Connection-Pool optimieren</a:t>
-            </a:r>
-            <a:endParaRPr lang="en-US" sz="1400" dirty="0"/>
-          </a:p>
-        </p:txBody>
-      </p:sp>
-      <p:sp>
-        <p:nvSpPr>
-          <p:cNvPr id="17" name="Text 15"/>
-          <p:cNvSpPr/>
-          <p:nvPr/>
-        </p:nvSpPr>
-        <p:spPr>
-          <a:xfrm>
-            <a:off x="4937760" y="4206240"/>
-            <a:ext cx="3703320" cy="502920"/>
-          </a:xfrm>
-          <a:prstGeom prst="rect">
-            <a:avLst/>
-          </a:prstGeom>
-          <a:noFill/>
-          <a:ln/>
-        </p:spPr>
-        <p:txBody>
-          <a:bodyPr wrap="square" lIns="0" tIns="0" rIns="0" bIns="0" rtlCol="0" anchor="ctr"/>
-          <a:lstStyle/>
-          <a:p>
-            <a:pPr marL="0" indent="0">
-              <a:lnSpc>
-                <a:spcPct val="100000"/>
-              </a:lnSpc>
-              <a:buNone/>
-            </a:pPr>
-            <a:r>
-              <a:rPr lang="en-US" sz="1050" b="1" dirty="0">
-                <a:solidFill>
-                  <a:srgbClr val="D9870B"/>
-                </a:solidFill>
-                <a:latin typeface="Calibri" pitchFamily="34" charset="0"/>
-                <a:ea typeface="Calibri" pitchFamily="34" charset="-122"/>
-                <a:cs typeface="Calibri" pitchFamily="34" charset="-120"/>
-              </a:rPr>
-              <a:t>Hinweis: </a:t>
-            </a:r>
-            <a:r>
-              <a:rPr lang="en-US" sz="1050" dirty="0">
-                <a:solidFill>
-                  <a:srgbClr val="5B6675"/>
-                </a:solidFill>
-                <a:latin typeface="Calibri" pitchFamily="34" charset="0"/>
-                <a:ea typeface="Calibri" pitchFamily="34" charset="-122"/>
-                <a:cs typeface="Calibri" pitchFamily="34" charset="-120"/>
-              </a:rPr>
-              <a:t>Tests liefen gegen localhost – die Obergrenze ist teils durch die Testmaschine limitiert.</a:t>
-            </a:r>
-            <a:endParaRPr lang="en-US" sz="1050" dirty="0"/>
-          </a:p>
-        </p:txBody>
-      </p:sp>
-      <p:sp>
-        <p:nvSpPr>
-          <p:cNvPr id="18" name="Text 16"/>
-          <p:cNvSpPr/>
-          <p:nvPr/>
-        </p:nvSpPr>
-        <p:spPr>
-          <a:xfrm>
-            <a:off x="8092440" y="4759452"/>
-            <a:ext cx="548640" cy="274320"/>
-          </a:xfrm>
-          <a:prstGeom prst="rect">
-            <a:avLst/>
-          </a:prstGeom>
-          <a:noFill/>
-          <a:ln/>
-        </p:spPr>
-        <p:txBody>
-          <a:bodyPr wrap="square" lIns="0" tIns="0" rIns="0" bIns="0" rtlCol="0" anchor="ctr"/>
-          <a:lstStyle/>
-          <a:p>
-            <a:pPr marL="0" indent="0" algn="r">
-              <a:buNone/>
-            </a:pPr>
-            <a:r>
-              <a:rPr lang="en-US" sz="1000" dirty="0">
-                <a:solidFill>
-                  <a:srgbClr val="5B6675"/>
-                </a:solidFill>
-                <a:latin typeface="Courier New" pitchFamily="34" charset="0"/>
-                <a:ea typeface="Courier New" pitchFamily="34" charset="-122"/>
-                <a:cs typeface="Courier New" pitchFamily="34" charset="-120"/>
-              </a:rPr>
-              <a:t>13</a:t>
-            </a:r>
-            <a:endParaRPr lang="en-US" sz="1000" dirty="0"/>
-          </a:p>
-        </p:txBody>
-      </p:sp>
-    </p:spTree>
-  </p:cSld>
-  <p:clrMapOvr>
-    <a:masterClrMapping/>
-  </p:clrMapOvr>
-</p:sld>
-</file>
-
-<file path=ppt/slides/slide13.xml><?xml version="1.0" encoding="utf-8"?>
 <p:sld xmlns:a="http://schemas.openxmlformats.org/drawingml/2006/main" xmlns:r="http://schemas.openxmlformats.org/officeDocument/2006/relationships" xmlns:p="http://schemas.openxmlformats.org/presentationml/2006/main">
   <p:cSld name="Slide 14">
     <p:bg>
@@ -4658,35 +3637,6 @@
       </p:sp>
       <p:sp>
         <p:nvSpPr>
-          <p:cNvPr id="13" name="Shape 11"/>
-          <p:cNvSpPr/>
-          <p:nvPr/>
-        </p:nvSpPr>
-        <p:spPr>
-          <a:xfrm>
-            <a:off x="502920" y="3337560"/>
-            <a:ext cx="8138160" cy="1371600"/>
-          </a:xfrm>
-          <a:prstGeom prst="roundRect">
-            <a:avLst>
-              <a:gd name="adj" fmla="val 5333"/>
-            </a:avLst>
-          </a:prstGeom>
-          <a:solidFill>
-            <a:srgbClr val="12181F"/>
-          </a:solidFill>
-          <a:ln/>
-        </p:spPr>
-        <p:txBody>
-          <a:bodyPr/>
-          <a:lstStyle/>
-          <a:p>
-            <a:endParaRPr lang="de-AT"/>
-          </a:p>
-        </p:txBody>
-      </p:sp>
-      <p:sp>
-        <p:nvSpPr>
           <p:cNvPr id="14" name="Text 12"/>
           <p:cNvSpPr/>
           <p:nvPr/>
@@ -4721,168 +3671,6 @@
               <a:t>Warum CI/CD? Test-Isolation als Qualitätsmerkmal</a:t>
             </a:r>
             <a:endParaRPr lang="en-US" sz="1500" dirty="0"/>
-          </a:p>
-        </p:txBody>
-      </p:sp>
-      <p:sp>
-        <p:nvSpPr>
-          <p:cNvPr id="15" name="Text 13"/>
-          <p:cNvSpPr/>
-          <p:nvPr/>
-        </p:nvSpPr>
-        <p:spPr>
-          <a:xfrm>
-            <a:off x="777240" y="3886200"/>
-            <a:ext cx="2346960" cy="731520"/>
-          </a:xfrm>
-          <a:prstGeom prst="rect">
-            <a:avLst/>
-          </a:prstGeom>
-          <a:noFill/>
-          <a:ln/>
-        </p:spPr>
-        <p:txBody>
-          <a:bodyPr wrap="square" lIns="0" tIns="0" rIns="0" bIns="0" rtlCol="0" anchor="ctr"/>
-          <a:lstStyle/>
-          <a:p>
-            <a:pPr marL="0" indent="0">
-              <a:lnSpc>
-                <a:spcPct val="105000"/>
-              </a:lnSpc>
-              <a:buNone/>
-            </a:pPr>
-            <a:r>
-              <a:rPr lang="en-US" sz="1250" b="1" dirty="0">
-                <a:solidFill>
-                  <a:srgbClr val="06B6D4"/>
-                </a:solidFill>
-                <a:latin typeface="Calibri" pitchFamily="34" charset="0"/>
-                <a:ea typeface="Calibri" pitchFamily="34" charset="-122"/>
-                <a:cs typeface="Calibri" pitchFamily="34" charset="-120"/>
-              </a:rPr>
-              <a:t>Keine externen Dienste
-</a:t>
-            </a:r>
-            <a:r>
-              <a:rPr lang="en-US" sz="1050" dirty="0">
-                <a:solidFill>
-                  <a:srgbClr val="C7D2DD"/>
-                </a:solidFill>
-                <a:latin typeface="Calibri" pitchFamily="34" charset="0"/>
-                <a:ea typeface="Calibri" pitchFamily="34" charset="-122"/>
-                <a:cs typeface="Calibri" pitchFamily="34" charset="-120"/>
-              </a:rPr>
-              <a:t>kein DB-Service nötig – läuft isoliert im Runner-Memory</a:t>
-            </a:r>
-            <a:endParaRPr lang="en-US" sz="1250" dirty="0"/>
-          </a:p>
-        </p:txBody>
-      </p:sp>
-      <p:sp>
-        <p:nvSpPr>
-          <p:cNvPr id="16" name="Text 14"/>
-          <p:cNvSpPr/>
-          <p:nvPr/>
-        </p:nvSpPr>
-        <p:spPr>
-          <a:xfrm>
-            <a:off x="3398520" y="3886200"/>
-            <a:ext cx="2346960" cy="731520"/>
-          </a:xfrm>
-          <a:prstGeom prst="rect">
-            <a:avLst/>
-          </a:prstGeom>
-          <a:noFill/>
-          <a:ln/>
-        </p:spPr>
-        <p:txBody>
-          <a:bodyPr wrap="square" lIns="0" tIns="0" rIns="0" bIns="0" rtlCol="0" anchor="ctr"/>
-          <a:lstStyle/>
-          <a:p>
-            <a:pPr marL="0" indent="0">
-              <a:lnSpc>
-                <a:spcPct val="105000"/>
-              </a:lnSpc>
-              <a:buNone/>
-            </a:pPr>
-            <a:r>
-              <a:rPr lang="en-US" sz="1250" b="1" dirty="0">
-                <a:solidFill>
-                  <a:srgbClr val="06B6D4"/>
-                </a:solidFill>
-                <a:latin typeface="Calibri" pitchFamily="34" charset="0"/>
-                <a:ea typeface="Calibri" pitchFamily="34" charset="-122"/>
-                <a:cs typeface="Calibri" pitchFamily="34" charset="-120"/>
-              </a:rPr>
-              <a:t>Deterministisch
-</a:t>
-            </a:r>
-            <a:r>
-              <a:rPr lang="en-US" sz="1050" dirty="0">
-                <a:solidFill>
-                  <a:srgbClr val="C7D2DD"/>
-                </a:solidFill>
-                <a:latin typeface="Calibri" pitchFamily="34" charset="0"/>
-                <a:ea typeface="Calibri" pitchFamily="34" charset="-122"/>
-                <a:cs typeface="Calibri" pitchFamily="34" charset="-120"/>
-              </a:rPr>
-              <a:t>npm ci nutzt exakt die gelockten Paketversionen</a:t>
-            </a:r>
-            <a:endParaRPr lang="en-US" sz="1250" dirty="0"/>
-          </a:p>
-        </p:txBody>
-      </p:sp>
-      <p:sp>
-        <p:nvSpPr>
-          <p:cNvPr id="17" name="Text 15"/>
-          <p:cNvSpPr/>
-          <p:nvPr/>
-        </p:nvSpPr>
-        <p:spPr>
-          <a:xfrm>
-            <a:off x="6019800" y="3886200"/>
-            <a:ext cx="2346960" cy="731520"/>
-          </a:xfrm>
-          <a:prstGeom prst="rect">
-            <a:avLst/>
-          </a:prstGeom>
-          <a:noFill/>
-          <a:ln/>
-        </p:spPr>
-        <p:txBody>
-          <a:bodyPr wrap="square" lIns="0" tIns="0" rIns="0" bIns="0" rtlCol="0" anchor="ctr"/>
-          <a:lstStyle/>
-          <a:p>
-            <a:pPr marL="0" indent="0">
-              <a:lnSpc>
-                <a:spcPct val="105000"/>
-              </a:lnSpc>
-              <a:buNone/>
-            </a:pPr>
-            <a:r>
-              <a:rPr lang="en-US" sz="1250" b="1" dirty="0">
-                <a:solidFill>
-                  <a:srgbClr val="06B6D4"/>
-                </a:solidFill>
-                <a:latin typeface="Calibri" pitchFamily="34" charset="0"/>
-                <a:ea typeface="Calibri" pitchFamily="34" charset="-122"/>
-                <a:cs typeface="Calibri" pitchFamily="34" charset="-120"/>
-              </a:rPr>
-              <a:t>Caching
-</a:t>
-            </a:r>
-            <a:r>
-              <a:rPr lang="en-US" sz="1050" dirty="0">
-                <a:solidFill>
-                  <a:srgbClr val="C7D2DD"/>
-                </a:solidFill>
-                <a:latin typeface="Calibri" pitchFamily="34" charset="0"/>
-                <a:ea typeface="Calibri" pitchFamily="34" charset="-122"/>
-                <a:cs typeface="Calibri" pitchFamily="34" charset="-120"/>
-              </a:rPr>
-              <a:t>cache: 'npm' → Installation in Sekunden</a:t>
-            </a:r>
-            <a:endParaRPr lang="en-US" sz="1250" dirty="0"/>
           </a:p>
         </p:txBody>
       </p:sp>
@@ -4922,666 +3710,6 @@
               <a:t>14</a:t>
             </a:r>
             <a:endParaRPr lang="en-US" sz="1000" dirty="0"/>
-          </a:p>
-        </p:txBody>
-      </p:sp>
-    </p:spTree>
-  </p:cSld>
-  <p:clrMapOvr>
-    <a:masterClrMapping/>
-  </p:clrMapOvr>
-</p:sld>
-</file>
-
-<file path=ppt/slides/slide14.xml><?xml version="1.0" encoding="utf-8"?>
-<p:sld xmlns:a="http://schemas.openxmlformats.org/drawingml/2006/main" xmlns:r="http://schemas.openxmlformats.org/officeDocument/2006/relationships" xmlns:p="http://schemas.openxmlformats.org/presentationml/2006/main">
-  <p:cSld name="Slide 15">
-    <p:bg>
-      <p:bgPr>
-        <a:solidFill>
-          <a:srgbClr val="12181F"/>
-        </a:solidFill>
-        <a:effectLst/>
-      </p:bgPr>
-    </p:bg>
-    <p:spTree>
-      <p:nvGrpSpPr>
-        <p:cNvPr id="1" name=""/>
-        <p:cNvGrpSpPr/>
-        <p:nvPr/>
-      </p:nvGrpSpPr>
-      <p:grpSpPr>
-        <a:xfrm>
-          <a:off x="0" y="0"/>
-          <a:ext cx="0" cy="0"/>
-          <a:chOff x="0" y="0"/>
-          <a:chExt cx="0" cy="0"/>
-        </a:xfrm>
-      </p:grpSpPr>
-      <p:sp>
-        <p:nvSpPr>
-          <p:cNvPr id="2" name="Text 0"/>
-          <p:cNvSpPr/>
-          <p:nvPr/>
-        </p:nvSpPr>
-        <p:spPr>
-          <a:xfrm>
-            <a:off x="502920" y="1005840"/>
-            <a:ext cx="8138160" cy="822960"/>
-          </a:xfrm>
-          <a:prstGeom prst="rect">
-            <a:avLst/>
-          </a:prstGeom>
-          <a:noFill/>
-          <a:ln/>
-        </p:spPr>
-        <p:txBody>
-          <a:bodyPr wrap="square" lIns="0" tIns="0" rIns="0" bIns="0" rtlCol="0" anchor="ctr"/>
-          <a:lstStyle/>
-          <a:p>
-            <a:pPr marL="0" indent="0">
-              <a:buNone/>
-            </a:pPr>
-            <a:r>
-              <a:rPr lang="en-US" sz="2800" b="1" dirty="0">
-                <a:solidFill>
-                  <a:srgbClr val="FFFFFF"/>
-                </a:solidFill>
-                <a:latin typeface="Calibri" pitchFamily="34" charset="0"/>
-                <a:ea typeface="Calibri" pitchFamily="34" charset="-122"/>
-                <a:cs typeface="Calibri" pitchFamily="34" charset="-120"/>
-              </a:rPr>
-              <a:t>Vollständig getestet – funktional &amp; unter Last</a:t>
-            </a:r>
-            <a:endParaRPr lang="en-US" sz="2800" dirty="0"/>
-          </a:p>
-        </p:txBody>
-      </p:sp>
-      <p:sp>
-        <p:nvSpPr>
-          <p:cNvPr id="3" name="Shape 1"/>
-          <p:cNvSpPr/>
-          <p:nvPr/>
-        </p:nvSpPr>
-        <p:spPr>
-          <a:xfrm>
-            <a:off x="502920" y="2048256"/>
-            <a:ext cx="310896" cy="310896"/>
-          </a:xfrm>
-          <a:prstGeom prst="ellipse">
-            <a:avLst/>
-          </a:prstGeom>
-          <a:solidFill>
-            <a:srgbClr val="0E7490"/>
-          </a:solidFill>
-          <a:ln/>
-        </p:spPr>
-        <p:txBody>
-          <a:bodyPr/>
-          <a:lstStyle/>
-          <a:p>
-            <a:endParaRPr lang="de-AT"/>
-          </a:p>
-        </p:txBody>
-      </p:sp>
-      <p:sp>
-        <p:nvSpPr>
-          <p:cNvPr id="4" name="Text 2"/>
-          <p:cNvSpPr/>
-          <p:nvPr/>
-        </p:nvSpPr>
-        <p:spPr>
-          <a:xfrm>
-            <a:off x="502920" y="2048256"/>
-            <a:ext cx="310896" cy="310896"/>
-          </a:xfrm>
-          <a:prstGeom prst="rect">
-            <a:avLst/>
-          </a:prstGeom>
-          <a:noFill/>
-          <a:ln/>
-        </p:spPr>
-        <p:txBody>
-          <a:bodyPr wrap="square" lIns="0" tIns="0" rIns="0" bIns="0" rtlCol="0" anchor="ctr"/>
-          <a:lstStyle/>
-          <a:p>
-            <a:pPr marL="0" indent="0" algn="ctr">
-              <a:buNone/>
-            </a:pPr>
-            <a:r>
-              <a:rPr lang="en-US" sz="1500" b="1" dirty="0">
-                <a:solidFill>
-                  <a:srgbClr val="FFFFFF"/>
-                </a:solidFill>
-                <a:latin typeface="Calibri" pitchFamily="34" charset="0"/>
-                <a:ea typeface="Calibri" pitchFamily="34" charset="-122"/>
-                <a:cs typeface="Calibri" pitchFamily="34" charset="-120"/>
-              </a:rPr>
-              <a:t>✓</a:t>
-            </a:r>
-            <a:endParaRPr lang="en-US" sz="1500" dirty="0"/>
-          </a:p>
-        </p:txBody>
-      </p:sp>
-      <p:sp>
-        <p:nvSpPr>
-          <p:cNvPr id="5" name="Text 3"/>
-          <p:cNvSpPr/>
-          <p:nvPr/>
-        </p:nvSpPr>
-        <p:spPr>
-          <a:xfrm>
-            <a:off x="960120" y="1956816"/>
-            <a:ext cx="3566160" cy="868680"/>
-          </a:xfrm>
-          <a:prstGeom prst="rect">
-            <a:avLst/>
-          </a:prstGeom>
-          <a:noFill/>
-          <a:ln/>
-        </p:spPr>
-        <p:txBody>
-          <a:bodyPr wrap="square" lIns="0" tIns="0" rIns="0" bIns="0" rtlCol="0" anchor="ctr"/>
-          <a:lstStyle/>
-          <a:p>
-            <a:pPr marL="0" indent="0">
-              <a:lnSpc>
-                <a:spcPct val="106000"/>
-              </a:lnSpc>
-              <a:buNone/>
-            </a:pPr>
-            <a:r>
-              <a:rPr lang="en-US" sz="1500" b="1" dirty="0">
-                <a:solidFill>
-                  <a:srgbClr val="FFFFFF"/>
-                </a:solidFill>
-                <a:latin typeface="Calibri" pitchFamily="34" charset="0"/>
-                <a:ea typeface="Calibri" pitchFamily="34" charset="-122"/>
-                <a:cs typeface="Calibri" pitchFamily="34" charset="-120"/>
-              </a:rPr>
-              <a:t>Architektur-getrieben
-</a:t>
-            </a:r>
-            <a:r>
-              <a:rPr lang="en-US" sz="1150" dirty="0">
-                <a:solidFill>
-                  <a:srgbClr val="C7D2DD"/>
-                </a:solidFill>
-                <a:latin typeface="Calibri" pitchFamily="34" charset="0"/>
-                <a:ea typeface="Calibri" pitchFamily="34" charset="-122"/>
-                <a:cs typeface="Calibri" pitchFamily="34" charset="-120"/>
-              </a:rPr>
-              <a:t>Jede Ebene testet das Risiko aus der DB-losen Architektur</a:t>
-            </a:r>
-            <a:endParaRPr lang="en-US" sz="1500" dirty="0"/>
-          </a:p>
-        </p:txBody>
-      </p:sp>
-      <p:sp>
-        <p:nvSpPr>
-          <p:cNvPr id="6" name="Shape 4"/>
-          <p:cNvSpPr/>
-          <p:nvPr/>
-        </p:nvSpPr>
-        <p:spPr>
-          <a:xfrm>
-            <a:off x="4800600" y="2048256"/>
-            <a:ext cx="310896" cy="310896"/>
-          </a:xfrm>
-          <a:prstGeom prst="ellipse">
-            <a:avLst/>
-          </a:prstGeom>
-          <a:solidFill>
-            <a:srgbClr val="0E7490"/>
-          </a:solidFill>
-          <a:ln/>
-        </p:spPr>
-        <p:txBody>
-          <a:bodyPr/>
-          <a:lstStyle/>
-          <a:p>
-            <a:endParaRPr lang="de-AT"/>
-          </a:p>
-        </p:txBody>
-      </p:sp>
-      <p:sp>
-        <p:nvSpPr>
-          <p:cNvPr id="7" name="Text 5"/>
-          <p:cNvSpPr/>
-          <p:nvPr/>
-        </p:nvSpPr>
-        <p:spPr>
-          <a:xfrm>
-            <a:off x="4800600" y="2048256"/>
-            <a:ext cx="310896" cy="310896"/>
-          </a:xfrm>
-          <a:prstGeom prst="rect">
-            <a:avLst/>
-          </a:prstGeom>
-          <a:noFill/>
-          <a:ln/>
-        </p:spPr>
-        <p:txBody>
-          <a:bodyPr wrap="square" lIns="0" tIns="0" rIns="0" bIns="0" rtlCol="0" anchor="ctr"/>
-          <a:lstStyle/>
-          <a:p>
-            <a:pPr marL="0" indent="0" algn="ctr">
-              <a:buNone/>
-            </a:pPr>
-            <a:r>
-              <a:rPr lang="en-US" sz="1500" b="1" dirty="0">
-                <a:solidFill>
-                  <a:srgbClr val="FFFFFF"/>
-                </a:solidFill>
-                <a:latin typeface="Calibri" pitchFamily="34" charset="0"/>
-                <a:ea typeface="Calibri" pitchFamily="34" charset="-122"/>
-                <a:cs typeface="Calibri" pitchFamily="34" charset="-120"/>
-              </a:rPr>
-              <a:t>✓</a:t>
-            </a:r>
-            <a:endParaRPr lang="en-US" sz="1500" dirty="0"/>
-          </a:p>
-        </p:txBody>
-      </p:sp>
-      <p:sp>
-        <p:nvSpPr>
-          <p:cNvPr id="8" name="Text 6"/>
-          <p:cNvSpPr/>
-          <p:nvPr/>
-        </p:nvSpPr>
-        <p:spPr>
-          <a:xfrm>
-            <a:off x="5257800" y="1956816"/>
-            <a:ext cx="3566160" cy="868680"/>
-          </a:xfrm>
-          <a:prstGeom prst="rect">
-            <a:avLst/>
-          </a:prstGeom>
-          <a:noFill/>
-          <a:ln/>
-        </p:spPr>
-        <p:txBody>
-          <a:bodyPr wrap="square" lIns="0" tIns="0" rIns="0" bIns="0" rtlCol="0" anchor="ctr"/>
-          <a:lstStyle/>
-          <a:p>
-            <a:pPr marL="0" indent="0">
-              <a:lnSpc>
-                <a:spcPct val="106000"/>
-              </a:lnSpc>
-              <a:buNone/>
-            </a:pPr>
-            <a:r>
-              <a:rPr lang="en-US" sz="1500" b="1" dirty="0">
-                <a:solidFill>
-                  <a:srgbClr val="FFFFFF"/>
-                </a:solidFill>
-                <a:latin typeface="Calibri" pitchFamily="34" charset="0"/>
-                <a:ea typeface="Calibri" pitchFamily="34" charset="-122"/>
-                <a:cs typeface="Calibri" pitchFamily="34" charset="-120"/>
-              </a:rPr>
-              <a:t>Belastbar
-</a:t>
-            </a:r>
-            <a:r>
-              <a:rPr lang="en-US" sz="1150" dirty="0">
-                <a:solidFill>
-                  <a:srgbClr val="C7D2DD"/>
-                </a:solidFill>
-                <a:latin typeface="Calibri" pitchFamily="34" charset="0"/>
-                <a:ea typeface="Calibri" pitchFamily="34" charset="-122"/>
-                <a:cs typeface="Calibri" pitchFamily="34" charset="-120"/>
-              </a:rPr>
-              <a:t>Solide bis ~500 Nutzer; Sättigung &amp; Breaking Point identifiziert</a:t>
-            </a:r>
-            <a:endParaRPr lang="en-US" sz="1500" dirty="0"/>
-          </a:p>
-        </p:txBody>
-      </p:sp>
-      <p:sp>
-        <p:nvSpPr>
-          <p:cNvPr id="9" name="Shape 7"/>
-          <p:cNvSpPr/>
-          <p:nvPr/>
-        </p:nvSpPr>
-        <p:spPr>
-          <a:xfrm>
-            <a:off x="502920" y="3191256"/>
-            <a:ext cx="310896" cy="310896"/>
-          </a:xfrm>
-          <a:prstGeom prst="ellipse">
-            <a:avLst/>
-          </a:prstGeom>
-          <a:solidFill>
-            <a:srgbClr val="0E7490"/>
-          </a:solidFill>
-          <a:ln/>
-        </p:spPr>
-        <p:txBody>
-          <a:bodyPr/>
-          <a:lstStyle/>
-          <a:p>
-            <a:endParaRPr lang="de-AT"/>
-          </a:p>
-        </p:txBody>
-      </p:sp>
-      <p:sp>
-        <p:nvSpPr>
-          <p:cNvPr id="10" name="Text 8"/>
-          <p:cNvSpPr/>
-          <p:nvPr/>
-        </p:nvSpPr>
-        <p:spPr>
-          <a:xfrm>
-            <a:off x="502920" y="3191256"/>
-            <a:ext cx="310896" cy="310896"/>
-          </a:xfrm>
-          <a:prstGeom prst="rect">
-            <a:avLst/>
-          </a:prstGeom>
-          <a:noFill/>
-          <a:ln/>
-        </p:spPr>
-        <p:txBody>
-          <a:bodyPr wrap="square" lIns="0" tIns="0" rIns="0" bIns="0" rtlCol="0" anchor="ctr"/>
-          <a:lstStyle/>
-          <a:p>
-            <a:pPr marL="0" indent="0" algn="ctr">
-              <a:buNone/>
-            </a:pPr>
-            <a:r>
-              <a:rPr lang="en-US" sz="1500" b="1" dirty="0">
-                <a:solidFill>
-                  <a:srgbClr val="FFFFFF"/>
-                </a:solidFill>
-                <a:latin typeface="Calibri" pitchFamily="34" charset="0"/>
-                <a:ea typeface="Calibri" pitchFamily="34" charset="-122"/>
-                <a:cs typeface="Calibri" pitchFamily="34" charset="-120"/>
-              </a:rPr>
-              <a:t>✓</a:t>
-            </a:r>
-            <a:endParaRPr lang="en-US" sz="1500" dirty="0"/>
-          </a:p>
-        </p:txBody>
-      </p:sp>
-      <p:sp>
-        <p:nvSpPr>
-          <p:cNvPr id="11" name="Text 9"/>
-          <p:cNvSpPr/>
-          <p:nvPr/>
-        </p:nvSpPr>
-        <p:spPr>
-          <a:xfrm>
-            <a:off x="960120" y="3099816"/>
-            <a:ext cx="3566160" cy="868680"/>
-          </a:xfrm>
-          <a:prstGeom prst="rect">
-            <a:avLst/>
-          </a:prstGeom>
-          <a:noFill/>
-          <a:ln/>
-        </p:spPr>
-        <p:txBody>
-          <a:bodyPr wrap="square" lIns="0" tIns="0" rIns="0" bIns="0" rtlCol="0" anchor="ctr"/>
-          <a:lstStyle/>
-          <a:p>
-            <a:pPr marL="0" indent="0">
-              <a:lnSpc>
-                <a:spcPct val="106000"/>
-              </a:lnSpc>
-              <a:buNone/>
-            </a:pPr>
-            <a:r>
-              <a:rPr lang="en-US" sz="1500" b="1" dirty="0">
-                <a:solidFill>
-                  <a:srgbClr val="FFFFFF"/>
-                </a:solidFill>
-                <a:latin typeface="Calibri" pitchFamily="34" charset="0"/>
-                <a:ea typeface="Calibri" pitchFamily="34" charset="-122"/>
-                <a:cs typeface="Calibri" pitchFamily="34" charset="-120"/>
-              </a:rPr>
-              <a:t>Ehrlich
-</a:t>
-            </a:r>
-            <a:r>
-              <a:rPr lang="en-US" sz="1150" dirty="0">
-                <a:solidFill>
-                  <a:srgbClr val="C7D2DD"/>
-                </a:solidFill>
-                <a:latin typeface="Calibri" pitchFamily="34" charset="0"/>
-                <a:ea typeface="Calibri" pitchFamily="34" charset="-122"/>
-                <a:cs typeface="Calibri" pitchFamily="34" charset="-120"/>
-              </a:rPr>
-              <a:t>Bekannte Schwächen bewusst als rote / 500-Tests dokumentiert</a:t>
-            </a:r>
-            <a:endParaRPr lang="en-US" sz="1500" dirty="0"/>
-          </a:p>
-        </p:txBody>
-      </p:sp>
-      <p:sp>
-        <p:nvSpPr>
-          <p:cNvPr id="12" name="Shape 10"/>
-          <p:cNvSpPr/>
-          <p:nvPr/>
-        </p:nvSpPr>
-        <p:spPr>
-          <a:xfrm>
-            <a:off x="4800600" y="3191256"/>
-            <a:ext cx="310896" cy="310896"/>
-          </a:xfrm>
-          <a:prstGeom prst="ellipse">
-            <a:avLst/>
-          </a:prstGeom>
-          <a:solidFill>
-            <a:srgbClr val="0E7490"/>
-          </a:solidFill>
-          <a:ln/>
-        </p:spPr>
-        <p:txBody>
-          <a:bodyPr/>
-          <a:lstStyle/>
-          <a:p>
-            <a:endParaRPr lang="de-AT"/>
-          </a:p>
-        </p:txBody>
-      </p:sp>
-      <p:sp>
-        <p:nvSpPr>
-          <p:cNvPr id="13" name="Text 11"/>
-          <p:cNvSpPr/>
-          <p:nvPr/>
-        </p:nvSpPr>
-        <p:spPr>
-          <a:xfrm>
-            <a:off x="4800600" y="3191256"/>
-            <a:ext cx="310896" cy="310896"/>
-          </a:xfrm>
-          <a:prstGeom prst="rect">
-            <a:avLst/>
-          </a:prstGeom>
-          <a:noFill/>
-          <a:ln/>
-        </p:spPr>
-        <p:txBody>
-          <a:bodyPr wrap="square" lIns="0" tIns="0" rIns="0" bIns="0" rtlCol="0" anchor="ctr"/>
-          <a:lstStyle/>
-          <a:p>
-            <a:pPr marL="0" indent="0" algn="ctr">
-              <a:buNone/>
-            </a:pPr>
-            <a:r>
-              <a:rPr lang="en-US" sz="1500" b="1" dirty="0">
-                <a:solidFill>
-                  <a:srgbClr val="FFFFFF"/>
-                </a:solidFill>
-                <a:latin typeface="Calibri" pitchFamily="34" charset="0"/>
-                <a:ea typeface="Calibri" pitchFamily="34" charset="-122"/>
-                <a:cs typeface="Calibri" pitchFamily="34" charset="-120"/>
-              </a:rPr>
-              <a:t>✓</a:t>
-            </a:r>
-            <a:endParaRPr lang="en-US" sz="1500" dirty="0"/>
-          </a:p>
-        </p:txBody>
-      </p:sp>
-      <p:sp>
-        <p:nvSpPr>
-          <p:cNvPr id="14" name="Text 12"/>
-          <p:cNvSpPr/>
-          <p:nvPr/>
-        </p:nvSpPr>
-        <p:spPr>
-          <a:xfrm>
-            <a:off x="5257800" y="3099816"/>
-            <a:ext cx="3566160" cy="868680"/>
-          </a:xfrm>
-          <a:prstGeom prst="rect">
-            <a:avLst/>
-          </a:prstGeom>
-          <a:noFill/>
-          <a:ln/>
-        </p:spPr>
-        <p:txBody>
-          <a:bodyPr wrap="square" lIns="0" tIns="0" rIns="0" bIns="0" rtlCol="0" anchor="ctr"/>
-          <a:lstStyle/>
-          <a:p>
-            <a:pPr marL="0" indent="0">
-              <a:lnSpc>
-                <a:spcPct val="106000"/>
-              </a:lnSpc>
-              <a:buNone/>
-            </a:pPr>
-            <a:r>
-              <a:rPr lang="en-US" sz="1500" b="1" dirty="0">
-                <a:solidFill>
-                  <a:srgbClr val="FFFFFF"/>
-                </a:solidFill>
-                <a:latin typeface="Calibri" pitchFamily="34" charset="0"/>
-                <a:ea typeface="Calibri" pitchFamily="34" charset="-122"/>
-                <a:cs typeface="Calibri" pitchFamily="34" charset="-120"/>
-              </a:rPr>
-              <a:t>Automatisiert
-</a:t>
-            </a:r>
-            <a:r>
-              <a:rPr lang="en-US" sz="1150" dirty="0">
-                <a:solidFill>
-                  <a:srgbClr val="C7D2DD"/>
-                </a:solidFill>
-                <a:latin typeface="Calibri" pitchFamily="34" charset="0"/>
-                <a:ea typeface="Calibri" pitchFamily="34" charset="-122"/>
-                <a:cs typeface="Calibri" pitchFamily="34" charset="-120"/>
-              </a:rPr>
-              <a:t>CI/CD prüft jede Änderung isoliert &amp; deterministisch</a:t>
-            </a:r>
-            <a:endParaRPr lang="en-US" sz="1500" dirty="0"/>
-          </a:p>
-        </p:txBody>
-      </p:sp>
-      <p:sp>
-        <p:nvSpPr>
-          <p:cNvPr id="15" name="Shape 13"/>
-          <p:cNvSpPr/>
-          <p:nvPr/>
-        </p:nvSpPr>
-        <p:spPr>
-          <a:xfrm>
-            <a:off x="502920" y="4572000"/>
-            <a:ext cx="8138160" cy="0"/>
-          </a:xfrm>
-          <a:prstGeom prst="line">
-            <a:avLst/>
-          </a:prstGeom>
-          <a:noFill/>
-          <a:ln w="12700">
-            <a:solidFill>
-              <a:srgbClr val="2A3540"/>
-            </a:solidFill>
-            <a:prstDash val="solid"/>
-          </a:ln>
-        </p:spPr>
-        <p:txBody>
-          <a:bodyPr/>
-          <a:lstStyle/>
-          <a:p>
-            <a:endParaRPr lang="de-AT"/>
-          </a:p>
-        </p:txBody>
-      </p:sp>
-      <p:sp>
-        <p:nvSpPr>
-          <p:cNvPr id="16" name="Text 14"/>
-          <p:cNvSpPr/>
-          <p:nvPr/>
-        </p:nvSpPr>
-        <p:spPr>
-          <a:xfrm>
-            <a:off x="502920" y="4645152"/>
-            <a:ext cx="5486400" cy="274320"/>
-          </a:xfrm>
-          <a:prstGeom prst="rect">
-            <a:avLst/>
-          </a:prstGeom>
-          <a:noFill/>
-          <a:ln/>
-        </p:spPr>
-        <p:txBody>
-          <a:bodyPr wrap="square" lIns="0" tIns="0" rIns="0" bIns="0" rtlCol="0" anchor="ctr"/>
-          <a:lstStyle/>
-          <a:p>
-            <a:pPr marL="0" indent="0">
-              <a:buNone/>
-            </a:pPr>
-            <a:r>
-              <a:rPr lang="en-US" sz="1100" dirty="0">
-                <a:solidFill>
-                  <a:srgbClr val="5B6675"/>
-                </a:solidFill>
-                <a:latin typeface="Courier New" pitchFamily="34" charset="0"/>
-                <a:ea typeface="Courier New" pitchFamily="34" charset="-122"/>
-                <a:cs typeface="Courier New" pitchFamily="34" charset="-120"/>
-              </a:rPr>
-              <a:t>Andreas Pointner · Dominik Köberl</a:t>
-            </a:r>
-            <a:endParaRPr lang="en-US" sz="1100" dirty="0"/>
-          </a:p>
-        </p:txBody>
-      </p:sp>
-      <p:sp>
-        <p:nvSpPr>
-          <p:cNvPr id="17" name="Text 15"/>
-          <p:cNvSpPr/>
-          <p:nvPr/>
-        </p:nvSpPr>
-        <p:spPr>
-          <a:xfrm>
-            <a:off x="4983480" y="4617720"/>
-            <a:ext cx="3657600" cy="274320"/>
-          </a:xfrm>
-          <a:prstGeom prst="rect">
-            <a:avLst/>
-          </a:prstGeom>
-          <a:noFill/>
-          <a:ln/>
-        </p:spPr>
-        <p:txBody>
-          <a:bodyPr wrap="square" lIns="0" tIns="0" rIns="0" bIns="0" rtlCol="0" anchor="ctr"/>
-          <a:lstStyle/>
-          <a:p>
-            <a:pPr marL="0" indent="0" algn="r">
-              <a:buNone/>
-            </a:pPr>
-            <a:r>
-              <a:rPr lang="en-US" sz="1400" b="1" dirty="0">
-                <a:solidFill>
-                  <a:srgbClr val="06B6D4"/>
-                </a:solidFill>
-                <a:latin typeface="Calibri" pitchFamily="34" charset="0"/>
-                <a:ea typeface="Calibri" pitchFamily="34" charset="-122"/>
-                <a:cs typeface="Calibri" pitchFamily="34" charset="-120"/>
-              </a:rPr>
-              <a:t>Vielen Dank — Fragen?</a:t>
-            </a:r>
-            <a:endParaRPr lang="en-US" sz="1400" dirty="0"/>
           </a:p>
         </p:txBody>
       </p:sp>
@@ -6145,17 +4273,6 @@
               <a:buNone/>
             </a:pPr>
             <a:r>
-              <a:rPr lang="en-US" sz="1200" b="1" dirty="0">
-                <a:solidFill>
-                  <a:srgbClr val="0E7490"/>
-                </a:solidFill>
-                <a:latin typeface="Calibri" pitchFamily="34" charset="0"/>
-                <a:ea typeface="Calibri" pitchFamily="34" charset="-122"/>
-                <a:cs typeface="Calibri" pitchFamily="34" charset="-120"/>
-              </a:rPr>
-              <a:t>Warum relevant fürs Testen:  </a:t>
-            </a:r>
-            <a:r>
               <a:rPr lang="en-US" sz="1200" dirty="0">
                 <a:solidFill>
                   <a:srgbClr val="12181F"/>
@@ -6185,7 +4302,7 @@
         </p:blipFill>
         <p:spPr>
           <a:xfrm>
-            <a:off x="5900995" y="1280160"/>
+            <a:off x="5626675" y="854964"/>
             <a:ext cx="2740085" cy="3246120"/>
           </a:xfrm>
           <a:prstGeom prst="rect">
@@ -6503,7 +4620,7 @@
                 <a:ea typeface="Calibri" pitchFamily="34" charset="-122"/>
                 <a:cs typeface="Calibri" pitchFamily="34" charset="-120"/>
               </a:rPr>
-              <a:t>9 Integration · Jest</a:t>
+              <a:t>8 Integration · Jest</a:t>
             </a:r>
             <a:endParaRPr lang="en-US" sz="1250" dirty="0"/>
           </a:p>
@@ -6675,45 +4792,6 @@
                 <a:cs typeface="Courier New" pitchFamily="34" charset="-120"/>
               </a:rPr>
               <a:t>schnell · viele</a:t>
-            </a:r>
-            <a:endParaRPr lang="en-US" sz="1000" dirty="0"/>
-          </a:p>
-        </p:txBody>
-      </p:sp>
-      <p:sp>
-        <p:nvSpPr>
-          <p:cNvPr id="14" name="Text 12"/>
-          <p:cNvSpPr/>
-          <p:nvPr/>
-        </p:nvSpPr>
-        <p:spPr>
-          <a:xfrm>
-            <a:off x="502920" y="1417320"/>
-            <a:ext cx="1554480" cy="365760"/>
-          </a:xfrm>
-          <a:prstGeom prst="rect">
-            <a:avLst/>
-          </a:prstGeom>
-          <a:noFill/>
-          <a:ln/>
-        </p:spPr>
-        <p:txBody>
-          <a:bodyPr wrap="square" lIns="0" tIns="0" rIns="0" bIns="0" rtlCol="0" anchor="ctr"/>
-          <a:lstStyle/>
-          <a:p>
-            <a:pPr marL="0" indent="0" algn="ctr">
-              <a:buNone/>
-            </a:pPr>
-            <a:r>
-              <a:rPr lang="en-US" sz="1000" dirty="0">
-                <a:solidFill>
-                  <a:srgbClr val="5B6675"/>
-                </a:solidFill>
-                <a:latin typeface="Courier New" pitchFamily="34" charset="0"/>
-                <a:ea typeface="Courier New" pitchFamily="34" charset="-122"/>
-                <a:cs typeface="Courier New" pitchFamily="34" charset="-120"/>
-              </a:rPr>
-              <a:t>realistisch · wenige</a:t>
             </a:r>
             <a:endParaRPr lang="en-US" sz="1000" dirty="0"/>
           </a:p>
@@ -7141,45 +5219,6 @@
       </p:sp>
       <p:sp>
         <p:nvSpPr>
-          <p:cNvPr id="5" name="Text 3"/>
-          <p:cNvSpPr/>
-          <p:nvPr/>
-        </p:nvSpPr>
-        <p:spPr>
-          <a:xfrm>
-            <a:off x="502920" y="1078992"/>
-            <a:ext cx="4572000" cy="274320"/>
-          </a:xfrm>
-          <a:prstGeom prst="rect">
-            <a:avLst/>
-          </a:prstGeom>
-          <a:noFill/>
-          <a:ln/>
-        </p:spPr>
-        <p:txBody>
-          <a:bodyPr wrap="square" lIns="0" tIns="0" rIns="0" bIns="0" rtlCol="0" anchor="ctr"/>
-          <a:lstStyle/>
-          <a:p>
-            <a:pPr marL="0" indent="0">
-              <a:buNone/>
-            </a:pPr>
-            <a:r>
-              <a:rPr lang="en-US" sz="1200" b="1" dirty="0">
-                <a:solidFill>
-                  <a:srgbClr val="0E7490"/>
-                </a:solidFill>
-                <a:latin typeface="Courier New" pitchFamily="34" charset="0"/>
-                <a:ea typeface="Courier New" pitchFamily="34" charset="-122"/>
-                <a:cs typeface="Courier New" pitchFamily="34" charset="-120"/>
-              </a:rPr>
-              <a:t>npm test  ·  models/cart.js</a:t>
-            </a:r>
-            <a:endParaRPr lang="en-US" sz="1200" dirty="0"/>
-          </a:p>
-        </p:txBody>
-      </p:sp>
-      <p:sp>
-        <p:nvSpPr>
           <p:cNvPr id="6" name="Shape 4"/>
           <p:cNvSpPr/>
           <p:nvPr/>
@@ -10476,104 +8515,6 @@
       </p:sp>
       <p:sp>
         <p:nvSpPr>
-          <p:cNvPr id="42" name="Shape 40"/>
-          <p:cNvSpPr/>
-          <p:nvPr/>
-        </p:nvSpPr>
-        <p:spPr>
-          <a:xfrm>
-            <a:off x="502920" y="3931920"/>
-            <a:ext cx="8138160" cy="804672"/>
-          </a:xfrm>
-          <a:prstGeom prst="roundRect">
-            <a:avLst>
-              <a:gd name="adj" fmla="val 9091"/>
-            </a:avLst>
-          </a:prstGeom>
-          <a:solidFill>
-            <a:srgbClr val="EAF7FB"/>
-          </a:solidFill>
-          <a:ln w="12700">
-            <a:solidFill>
-              <a:srgbClr val="C5E8F1"/>
-            </a:solidFill>
-            <a:prstDash val="solid"/>
-          </a:ln>
-        </p:spPr>
-        <p:txBody>
-          <a:bodyPr/>
-          <a:lstStyle/>
-          <a:p>
-            <a:endParaRPr lang="de-AT"/>
-          </a:p>
-        </p:txBody>
-      </p:sp>
-      <p:sp>
-        <p:nvSpPr>
-          <p:cNvPr id="43" name="Text 41"/>
-          <p:cNvSpPr/>
-          <p:nvPr/>
-        </p:nvSpPr>
-        <p:spPr>
-          <a:xfrm>
-            <a:off x="731520" y="4023360"/>
-            <a:ext cx="7680960" cy="621792"/>
-          </a:xfrm>
-          <a:prstGeom prst="rect">
-            <a:avLst/>
-          </a:prstGeom>
-          <a:noFill/>
-          <a:ln/>
-        </p:spPr>
-        <p:txBody>
-          <a:bodyPr wrap="square" lIns="0" tIns="0" rIns="0" bIns="0" rtlCol="0" anchor="ctr"/>
-          <a:lstStyle/>
-          <a:p>
-            <a:pPr marL="0" indent="0">
-              <a:lnSpc>
-                <a:spcPct val="105000"/>
-              </a:lnSpc>
-              <a:buNone/>
-            </a:pPr>
-            <a:r>
-              <a:rPr lang="en-US" sz="1150" b="1" dirty="0">
-                <a:solidFill>
-                  <a:srgbClr val="0E7490"/>
-                </a:solidFill>
-                <a:latin typeface="Calibri" pitchFamily="34" charset="0"/>
-                <a:ea typeface="Calibri" pitchFamily="34" charset="-122"/>
-                <a:cs typeface="Calibri" pitchFamily="34" charset="-120"/>
-              </a:rPr>
-              <a:t>Bewusst gewählt:  </a:t>
-            </a:r>
-            <a:r>
-              <a:rPr lang="en-US" sz="1150" dirty="0">
-                <a:solidFill>
-                  <a:srgbClr val="12181F"/>
-                </a:solidFill>
-                <a:latin typeface="Calibri" pitchFamily="34" charset="0"/>
-                <a:ea typeface="Calibri" pitchFamily="34" charset="-122"/>
-                <a:cs typeface="Calibri" pitchFamily="34" charset="-120"/>
-              </a:rPr>
-              <a:t>der Floating-Point-Test (9,99 × 3), weil Preisfehler geschäftskritisch sind, und die Rekonstruktion aus der Session, weil der Warenkorb bei JEDEM Request neu aus dem Session-Objekt gebaut wird.  </a:t>
-            </a:r>
-            <a:r>
-              <a:rPr lang="en-US" sz="1150" b="1" dirty="0">
-                <a:solidFill>
-                  <a:srgbClr val="E0524B"/>
-                </a:solidFill>
-                <a:latin typeface="Calibri" pitchFamily="34" charset="0"/>
-                <a:ea typeface="Calibri" pitchFamily="34" charset="-122"/>
-                <a:cs typeface="Calibri" pitchFamily="34" charset="-120"/>
-              </a:rPr>
-              <a:t>✕ = bewusst rot.</a:t>
-            </a:r>
-            <a:endParaRPr lang="en-US" sz="1150" dirty="0"/>
-          </a:p>
-        </p:txBody>
-      </p:sp>
-      <p:sp>
-        <p:nvSpPr>
           <p:cNvPr id="44" name="Text 42"/>
           <p:cNvSpPr/>
           <p:nvPr/>
@@ -10751,45 +8692,6 @@
       </p:sp>
       <p:sp>
         <p:nvSpPr>
-          <p:cNvPr id="5" name="Text 3"/>
-          <p:cNvSpPr/>
-          <p:nvPr/>
-        </p:nvSpPr>
-        <p:spPr>
-          <a:xfrm>
-            <a:off x="502920" y="1078992"/>
-            <a:ext cx="4572000" cy="274320"/>
-          </a:xfrm>
-          <a:prstGeom prst="rect">
-            <a:avLst/>
-          </a:prstGeom>
-          <a:noFill/>
-          <a:ln/>
-        </p:spPr>
-        <p:txBody>
-          <a:bodyPr wrap="square" lIns="0" tIns="0" rIns="0" bIns="0" rtlCol="0" anchor="ctr"/>
-          <a:lstStyle/>
-          <a:p>
-            <a:pPr marL="0" indent="0">
-              <a:buNone/>
-            </a:pPr>
-            <a:r>
-              <a:rPr lang="en-US" sz="1200" b="1" dirty="0">
-                <a:solidFill>
-                  <a:srgbClr val="0E7490"/>
-                </a:solidFill>
-                <a:latin typeface="Courier New" pitchFamily="34" charset="0"/>
-                <a:ea typeface="Courier New" pitchFamily="34" charset="-122"/>
-                <a:cs typeface="Courier New" pitchFamily="34" charset="-120"/>
-              </a:rPr>
-              <a:t>npm test  ·  routes/index.js</a:t>
-            </a:r>
-            <a:endParaRPr lang="en-US" sz="1200" dirty="0"/>
-          </a:p>
-        </p:txBody>
-      </p:sp>
-      <p:sp>
-        <p:nvSpPr>
           <p:cNvPr id="6" name="Shape 4"/>
           <p:cNvSpPr/>
           <p:nvPr/>
@@ -10897,7 +8799,7 @@
             </a:r>
             <a:r>
               <a:rPr lang="de-AT" sz="1250" dirty="0"/>
-              <a:t>-Modell bringt nichts, wenn die Route es nicht korrekt in der Session speichert. Wir testen die Schnittstelle zwischen Routing und Session über echte HTTP-</a:t>
+              <a:t>-Modell bringt nichts, wenn die Route es nicht korrekt in der Session speichert. Wir testen die Schnittstelle zwischen Routing und Session über HTTP-</a:t>
             </a:r>
             <a:r>
               <a:rPr lang="de-AT" sz="1250" dirty="0" err="1"/>
@@ -10905,10 +8807,6 @@
             </a:r>
             <a:r>
               <a:rPr lang="de-AT" sz="1250" dirty="0"/>
-              <a:t> – ohne Browser, also schneller als E2E</a:t>
-            </a:r>
-            <a:r>
-              <a:rPr lang="de-AT" sz="1200" dirty="0"/>
               <a:t>.</a:t>
             </a:r>
             <a:endParaRPr lang="en-US" sz="1200" dirty="0"/>
@@ -11056,7 +8954,62 @@
                 <a:ea typeface="Calibri" pitchFamily="34" charset="-122"/>
                 <a:cs typeface="Calibri" pitchFamily="34" charset="-120"/>
               </a:rPr>
-              <a:t>Routen rendern Katalog &amp; Warenkorb korrekt</a:t>
+              <a:t>Routen </a:t>
+            </a:r>
+            <a:r>
+              <a:rPr lang="en-US" sz="1150" dirty="0" err="1">
+                <a:solidFill>
+                  <a:srgbClr val="12181F"/>
+                </a:solidFill>
+                <a:latin typeface="Calibri" pitchFamily="34" charset="0"/>
+                <a:ea typeface="Calibri" pitchFamily="34" charset="-122"/>
+                <a:cs typeface="Calibri" pitchFamily="34" charset="-120"/>
+              </a:rPr>
+              <a:t>leiten</a:t>
+            </a:r>
+            <a:r>
+              <a:rPr lang="en-US" sz="1150" dirty="0">
+                <a:solidFill>
+                  <a:srgbClr val="12181F"/>
+                </a:solidFill>
+                <a:latin typeface="Calibri" pitchFamily="34" charset="0"/>
+                <a:ea typeface="Calibri" pitchFamily="34" charset="-122"/>
+                <a:cs typeface="Calibri" pitchFamily="34" charset="-120"/>
+              </a:rPr>
+              <a:t> </a:t>
+            </a:r>
+            <a:r>
+              <a:rPr lang="en-US" sz="1150" dirty="0" err="1">
+                <a:solidFill>
+                  <a:srgbClr val="12181F"/>
+                </a:solidFill>
+                <a:latin typeface="Calibri" pitchFamily="34" charset="0"/>
+                <a:ea typeface="Calibri" pitchFamily="34" charset="-122"/>
+                <a:cs typeface="Calibri" pitchFamily="34" charset="-120"/>
+              </a:rPr>
+              <a:t>korrekt</a:t>
+            </a:r>
+            <a:r>
+              <a:rPr lang="en-US" sz="1150" dirty="0">
+                <a:solidFill>
+                  <a:srgbClr val="12181F"/>
+                </a:solidFill>
+                <a:latin typeface="Calibri" pitchFamily="34" charset="0"/>
+                <a:ea typeface="Calibri" pitchFamily="34" charset="-122"/>
+                <a:cs typeface="Calibri" pitchFamily="34" charset="-120"/>
+              </a:rPr>
+              <a:t> </a:t>
+            </a:r>
+            <a:r>
+              <a:rPr lang="en-US" sz="1150" dirty="0" err="1">
+                <a:solidFill>
+                  <a:srgbClr val="12181F"/>
+                </a:solidFill>
+                <a:latin typeface="Calibri" pitchFamily="34" charset="0"/>
+                <a:ea typeface="Calibri" pitchFamily="34" charset="-122"/>
+                <a:cs typeface="Calibri" pitchFamily="34" charset="-120"/>
+              </a:rPr>
+              <a:t>weiter</a:t>
             </a:r>
             <a:endParaRPr lang="en-US" sz="1150" dirty="0"/>
           </a:p>
@@ -12662,7 +10615,7 @@
                 <a:ea typeface="Calibri" pitchFamily="34" charset="-122"/>
                 <a:cs typeface="Calibri" pitchFamily="34" charset="-120"/>
               </a:rPr>
-              <a:t>9 Tests an Routen &amp; Session</a:t>
+              <a:t>8 Tests an Routen &amp; Session</a:t>
             </a:r>
             <a:endParaRPr lang="en-US" sz="2700" dirty="0"/>
           </a:p>
@@ -12703,7 +10656,7 @@
         </p:nvSpPr>
         <p:spPr>
           <a:xfrm>
-            <a:off x="502920" y="1371600"/>
+            <a:off x="448056" y="1369493"/>
             <a:ext cx="3977640" cy="2331720"/>
           </a:xfrm>
           <a:prstGeom prst="roundRect">
@@ -12877,7 +10830,51 @@
                 <a:ea typeface="Calibri" pitchFamily="34" charset="-122"/>
                 <a:cs typeface="Calibri" pitchFamily="34" charset="-120"/>
               </a:rPr>
-              <a:t>GET / rendert Katalog aus JSON</a:t>
+              <a:t>GET / </a:t>
+            </a:r>
+            <a:r>
+              <a:rPr lang="en-US" sz="1100" dirty="0" err="1">
+                <a:solidFill>
+                  <a:srgbClr val="12181F"/>
+                </a:solidFill>
+                <a:latin typeface="Calibri" pitchFamily="34" charset="0"/>
+                <a:ea typeface="Calibri" pitchFamily="34" charset="-122"/>
+                <a:cs typeface="Calibri" pitchFamily="34" charset="-120"/>
+              </a:rPr>
+              <a:t>Katalog</a:t>
+            </a:r>
+            <a:r>
+              <a:rPr lang="en-US" sz="1100" dirty="0">
+                <a:solidFill>
+                  <a:srgbClr val="12181F"/>
+                </a:solidFill>
+                <a:latin typeface="Calibri" pitchFamily="34" charset="0"/>
+                <a:ea typeface="Calibri" pitchFamily="34" charset="-122"/>
+                <a:cs typeface="Calibri" pitchFamily="34" charset="-120"/>
+              </a:rPr>
+              <a:t> view </a:t>
+            </a:r>
+            <a:r>
+              <a:rPr lang="en-US" sz="1100" dirty="0" err="1">
+                <a:solidFill>
+                  <a:srgbClr val="12181F"/>
+                </a:solidFill>
+                <a:latin typeface="Calibri" pitchFamily="34" charset="0"/>
+                <a:ea typeface="Calibri" pitchFamily="34" charset="-122"/>
+                <a:cs typeface="Calibri" pitchFamily="34" charset="-120"/>
+              </a:rPr>
+              <a:t>im</a:t>
+            </a:r>
+            <a:r>
+              <a:rPr lang="en-US" sz="1100" dirty="0">
+                <a:solidFill>
+                  <a:srgbClr val="12181F"/>
+                </a:solidFill>
+                <a:latin typeface="Calibri" pitchFamily="34" charset="0"/>
+                <a:ea typeface="Calibri" pitchFamily="34" charset="-122"/>
+                <a:cs typeface="Calibri" pitchFamily="34" charset="-120"/>
+              </a:rPr>
+              <a:t> response</a:t>
             </a:r>
             <a:endParaRPr lang="en-US" sz="1100" dirty="0"/>
           </a:p>
@@ -12985,7 +10982,40 @@
                 <a:ea typeface="Calibri" pitchFamily="34" charset="-122"/>
                 <a:cs typeface="Calibri" pitchFamily="34" charset="-120"/>
               </a:rPr>
-              <a:t>GET /cart leer ohne Session</a:t>
+              <a:t>GET /cart redirect </a:t>
+            </a:r>
+            <a:r>
+              <a:rPr lang="en-US" sz="1100" dirty="0" err="1">
+                <a:solidFill>
+                  <a:srgbClr val="12181F"/>
+                </a:solidFill>
+                <a:latin typeface="Calibri" pitchFamily="34" charset="0"/>
+                <a:ea typeface="Calibri" pitchFamily="34" charset="-122"/>
+                <a:cs typeface="Calibri" pitchFamily="34" charset="-120"/>
+              </a:rPr>
+              <a:t>zu</a:t>
+            </a:r>
+            <a:r>
+              <a:rPr lang="en-US" sz="1100" dirty="0">
+                <a:solidFill>
+                  <a:srgbClr val="12181F"/>
+                </a:solidFill>
+                <a:latin typeface="Calibri" pitchFamily="34" charset="0"/>
+                <a:ea typeface="Calibri" pitchFamily="34" charset="-122"/>
+                <a:cs typeface="Calibri" pitchFamily="34" charset="-120"/>
+              </a:rPr>
+              <a:t> </a:t>
+            </a:r>
+            <a:r>
+              <a:rPr lang="en-US" sz="1100" dirty="0" err="1">
+                <a:solidFill>
+                  <a:srgbClr val="12181F"/>
+                </a:solidFill>
+                <a:latin typeface="Calibri" pitchFamily="34" charset="0"/>
+                <a:ea typeface="Calibri" pitchFamily="34" charset="-122"/>
+                <a:cs typeface="Calibri" pitchFamily="34" charset="-120"/>
+              </a:rPr>
+              <a:t>Warenkorb</a:t>
             </a:r>
             <a:endParaRPr lang="en-US" sz="1100" dirty="0"/>
           </a:p>
@@ -13244,7 +11274,7 @@
           <a:bodyPr/>
           <a:lstStyle/>
           <a:p>
-            <a:endParaRPr lang="de-AT"/>
+            <a:endParaRPr lang="de-AT" dirty="0"/>
           </a:p>
         </p:txBody>
       </p:sp>
@@ -13403,7 +11433,7 @@
         </p:nvSpPr>
         <p:spPr>
           <a:xfrm>
-            <a:off x="4864608" y="2203704"/>
+            <a:off x="4864608" y="2235549"/>
             <a:ext cx="173736" cy="173736"/>
           </a:xfrm>
           <a:prstGeom prst="ellipse">
@@ -13430,7 +11460,7 @@
         </p:nvSpPr>
         <p:spPr>
           <a:xfrm>
-            <a:off x="4864608" y="2203704"/>
+            <a:off x="4861742" y="2235912"/>
             <a:ext cx="173736" cy="173736"/>
           </a:xfrm>
           <a:prstGeom prst="rect">
@@ -13469,7 +11499,7 @@
         </p:nvSpPr>
         <p:spPr>
           <a:xfrm>
-            <a:off x="5138928" y="2139696"/>
+            <a:off x="5138928" y="2201293"/>
             <a:ext cx="3374136" cy="356616"/>
           </a:xfrm>
           <a:prstGeom prst="rect">
@@ -13511,7 +11541,7 @@
         </p:nvSpPr>
         <p:spPr>
           <a:xfrm>
-            <a:off x="4864608" y="2560320"/>
+            <a:off x="4850892" y="2651760"/>
             <a:ext cx="173736" cy="173736"/>
           </a:xfrm>
           <a:prstGeom prst="ellipse">
@@ -13538,7 +11568,7 @@
         </p:nvSpPr>
         <p:spPr>
           <a:xfrm>
-            <a:off x="4864608" y="2560320"/>
+            <a:off x="4850892" y="2641473"/>
             <a:ext cx="173736" cy="173736"/>
           </a:xfrm>
           <a:prstGeom prst="rect">
@@ -13577,7 +11607,7 @@
         </p:nvSpPr>
         <p:spPr>
           <a:xfrm>
-            <a:off x="5138928" y="2496312"/>
+            <a:off x="5120640" y="2647188"/>
             <a:ext cx="3374136" cy="356616"/>
           </a:xfrm>
           <a:prstGeom prst="rect">
@@ -13619,7 +11649,7 @@
         </p:nvSpPr>
         <p:spPr>
           <a:xfrm>
-            <a:off x="4864608" y="2916936"/>
+            <a:off x="4864608" y="3164967"/>
             <a:ext cx="173736" cy="173736"/>
           </a:xfrm>
           <a:prstGeom prst="ellipse">
@@ -13634,7 +11664,7 @@
           <a:bodyPr/>
           <a:lstStyle/>
           <a:p>
-            <a:endParaRPr lang="de-AT"/>
+            <a:endParaRPr lang="de-AT" dirty="0"/>
           </a:p>
         </p:txBody>
       </p:sp>
@@ -13646,7 +11676,7 @@
         </p:nvSpPr>
         <p:spPr>
           <a:xfrm>
-            <a:off x="4864608" y="2916936"/>
+            <a:off x="4864608" y="3156733"/>
             <a:ext cx="173736" cy="173736"/>
           </a:xfrm>
           <a:prstGeom prst="rect">
@@ -13685,7 +11715,7 @@
         </p:nvSpPr>
         <p:spPr>
           <a:xfrm>
-            <a:off x="5138928" y="2852928"/>
+            <a:off x="5102352" y="3164967"/>
             <a:ext cx="3374136" cy="356616"/>
           </a:xfrm>
           <a:prstGeom prst="rect">
@@ -13698,11 +11728,10 @@
           <a:bodyPr wrap="square" lIns="0" tIns="0" rIns="0" bIns="0" rtlCol="0" anchor="t"/>
           <a:lstStyle/>
           <a:p>
-            <a:pPr marL="0" indent="0">
+            <a:pPr>
               <a:lnSpc>
                 <a:spcPct val="98000"/>
               </a:lnSpc>
-              <a:buNone/>
             </a:pPr>
             <a:r>
               <a:rPr lang="en-US" sz="1100" dirty="0">
@@ -13713,7 +11742,51 @@
                 <a:ea typeface="Calibri" pitchFamily="34" charset="-122"/>
                 <a:cs typeface="Calibri" pitchFamily="34" charset="-120"/>
               </a:rPr>
-              <a:t>/remove/999 → 500</a:t>
+              <a:t>/remove </a:t>
+            </a:r>
+            <a:r>
+              <a:rPr lang="en-US" sz="1100" dirty="0" err="1">
+                <a:solidFill>
+                  <a:srgbClr val="12181F"/>
+                </a:solidFill>
+                <a:latin typeface="Calibri" pitchFamily="34" charset="0"/>
+                <a:ea typeface="Calibri" pitchFamily="34" charset="-122"/>
+                <a:cs typeface="Calibri" pitchFamily="34" charset="-120"/>
+              </a:rPr>
+              <a:t>ohne</a:t>
+            </a:r>
+            <a:r>
+              <a:rPr lang="en-US" sz="1100" dirty="0">
+                <a:solidFill>
+                  <a:srgbClr val="12181F"/>
+                </a:solidFill>
+                <a:latin typeface="Calibri" pitchFamily="34" charset="0"/>
+                <a:ea typeface="Calibri" pitchFamily="34" charset="-122"/>
+                <a:cs typeface="Calibri" pitchFamily="34" charset="-120"/>
+              </a:rPr>
+              <a:t> </a:t>
+            </a:r>
+            <a:r>
+              <a:rPr lang="en-US" sz="1100" dirty="0" err="1">
+                <a:solidFill>
+                  <a:srgbClr val="12181F"/>
+                </a:solidFill>
+                <a:latin typeface="Calibri" pitchFamily="34" charset="0"/>
+                <a:ea typeface="Calibri" pitchFamily="34" charset="-122"/>
+                <a:cs typeface="Calibri" pitchFamily="34" charset="-120"/>
+              </a:rPr>
+              <a:t>Warenkorb</a:t>
+            </a:r>
+            <a:r>
+              <a:rPr lang="en-US" sz="1100" dirty="0">
+                <a:solidFill>
+                  <a:srgbClr val="12181F"/>
+                </a:solidFill>
+                <a:latin typeface="Calibri" pitchFamily="34" charset="0"/>
+                <a:ea typeface="Calibri" pitchFamily="34" charset="-122"/>
+                <a:cs typeface="Calibri" pitchFamily="34" charset="-120"/>
+              </a:rPr>
+              <a:t> → 500</a:t>
             </a:r>
             <a:endParaRPr lang="en-US" sz="1100" dirty="0"/>
           </a:p>
@@ -13721,7 +11794,7 @@
       </p:sp>
       <p:sp>
         <p:nvSpPr>
-          <p:cNvPr id="33" name="Shape 31"/>
+          <p:cNvPr id="34" name="Text 32"/>
           <p:cNvSpPr/>
           <p:nvPr/>
         </p:nvSpPr>
@@ -13730,33 +11803,6 @@
             <a:off x="4864608" y="3273552"/>
             <a:ext cx="173736" cy="173736"/>
           </a:xfrm>
-          <a:prstGeom prst="ellipse">
-            <a:avLst/>
-          </a:prstGeom>
-          <a:solidFill>
-            <a:srgbClr val="D9870B"/>
-          </a:solidFill>
-          <a:ln/>
-        </p:spPr>
-        <p:txBody>
-          <a:bodyPr/>
-          <a:lstStyle/>
-          <a:p>
-            <a:endParaRPr lang="de-AT"/>
-          </a:p>
-        </p:txBody>
-      </p:sp>
-      <p:sp>
-        <p:nvSpPr>
-          <p:cNvPr id="34" name="Text 32"/>
-          <p:cNvSpPr/>
-          <p:nvPr/>
-        </p:nvSpPr>
-        <p:spPr>
-          <a:xfrm>
-            <a:off x="4864608" y="3273552"/>
-            <a:ext cx="173736" cy="173736"/>
-          </a:xfrm>
           <a:prstGeom prst="rect">
             <a:avLst/>
           </a:prstGeom>
@@ -13770,60 +11816,7 @@
             <a:pPr marL="0" indent="0" algn="ctr">
               <a:buNone/>
             </a:pPr>
-            <a:r>
-              <a:rPr lang="en-US" sz="950" b="1" dirty="0">
-                <a:solidFill>
-                  <a:srgbClr val="FFFFFF"/>
-                </a:solidFill>
-                <a:latin typeface="Calibri" pitchFamily="34" charset="0"/>
-                <a:ea typeface="Calibri" pitchFamily="34" charset="-122"/>
-                <a:cs typeface="Calibri" pitchFamily="34" charset="-120"/>
-              </a:rPr>
-              <a:t>!</a:t>
-            </a:r>
             <a:endParaRPr lang="en-US" sz="950" dirty="0"/>
-          </a:p>
-        </p:txBody>
-      </p:sp>
-      <p:sp>
-        <p:nvSpPr>
-          <p:cNvPr id="35" name="Text 33"/>
-          <p:cNvSpPr/>
-          <p:nvPr/>
-        </p:nvSpPr>
-        <p:spPr>
-          <a:xfrm>
-            <a:off x="5138928" y="3209544"/>
-            <a:ext cx="3374136" cy="356616"/>
-          </a:xfrm>
-          <a:prstGeom prst="rect">
-            <a:avLst/>
-          </a:prstGeom>
-          <a:noFill/>
-          <a:ln/>
-        </p:spPr>
-        <p:txBody>
-          <a:bodyPr wrap="square" lIns="0" tIns="0" rIns="0" bIns="0" rtlCol="0" anchor="t"/>
-          <a:lstStyle/>
-          <a:p>
-            <a:pPr marL="0" indent="0">
-              <a:lnSpc>
-                <a:spcPct val="98000"/>
-              </a:lnSpc>
-              <a:buNone/>
-            </a:pPr>
-            <a:r>
-              <a:rPr lang="en-US" sz="1100" dirty="0">
-                <a:solidFill>
-                  <a:srgbClr val="12181F"/>
-                </a:solidFill>
-                <a:latin typeface="Calibri" pitchFamily="34" charset="0"/>
-                <a:ea typeface="Calibri" pitchFamily="34" charset="-122"/>
-                <a:cs typeface="Calibri" pitchFamily="34" charset="-120"/>
-              </a:rPr>
-              <a:t>/remove ohne Warenkorb → 500</a:t>
-            </a:r>
-            <a:endParaRPr lang="en-US" sz="1100" dirty="0"/>
           </a:p>
         </p:txBody>
       </p:sp>
@@ -13889,6 +11882,17 @@
               <a:buNone/>
             </a:pPr>
             <a:r>
+              <a:rPr lang="en-US" sz="1150" b="1" dirty="0" err="1">
+                <a:solidFill>
+                  <a:srgbClr val="0E7490"/>
+                </a:solidFill>
+                <a:latin typeface="Calibri" pitchFamily="34" charset="0"/>
+                <a:ea typeface="Calibri" pitchFamily="34" charset="-122"/>
+                <a:cs typeface="Calibri" pitchFamily="34" charset="-120"/>
+              </a:rPr>
+              <a:t>Zusatzinfo</a:t>
+            </a:r>
+            <a:r>
               <a:rPr lang="en-US" sz="1150" b="1" dirty="0">
                 <a:solidFill>
                   <a:srgbClr val="0E7490"/>
@@ -13897,7 +11901,7 @@
                 <a:ea typeface="Calibri" pitchFamily="34" charset="-122"/>
                 <a:cs typeface="Calibri" pitchFamily="34" charset="-120"/>
               </a:rPr>
-              <a:t>Bewusst gewählt:  </a:t>
+              <a:t>:  </a:t>
             </a:r>
             <a:r>
               <a:rPr lang="en-US" sz="1150" dirty="0">
@@ -13919,7 +11923,7 @@
                 <a:ea typeface="Calibri" pitchFamily="34" charset="-122"/>
                 <a:cs typeface="Calibri" pitchFamily="34" charset="-120"/>
               </a:rPr>
-              <a:t>! = 500er-Fälle</a:t>
+              <a:t>     500er-Fälle</a:t>
             </a:r>
             <a:r>
               <a:rPr lang="en-US" sz="1150" dirty="0">
@@ -13930,7 +11934,29 @@
                 <a:ea typeface="Calibri" pitchFamily="34" charset="-122"/>
                 <a:cs typeface="Calibri" pitchFamily="34" charset="-120"/>
               </a:rPr>
-              <a:t> prüfen wir bewusst, um die fehlende Eingabe-Validierung der Routen festzuhalten (aktueller Ist-Zustand).</a:t>
+              <a:t> prüfen wir bewusst, um die fehlende Eingabe-Validierung der Routen </a:t>
+            </a:r>
+            <a:r>
+              <a:rPr lang="en-US" sz="1150" dirty="0" err="1">
+                <a:solidFill>
+                  <a:srgbClr val="12181F"/>
+                </a:solidFill>
+                <a:latin typeface="Calibri" pitchFamily="34" charset="0"/>
+                <a:ea typeface="Calibri" pitchFamily="34" charset="-122"/>
+                <a:cs typeface="Calibri" pitchFamily="34" charset="-120"/>
+              </a:rPr>
+              <a:t>festzuhalten</a:t>
+            </a:r>
+            <a:r>
+              <a:rPr lang="en-US" sz="1150" dirty="0">
+                <a:solidFill>
+                  <a:srgbClr val="12181F"/>
+                </a:solidFill>
+                <a:latin typeface="Calibri" pitchFamily="34" charset="0"/>
+                <a:ea typeface="Calibri" pitchFamily="34" charset="-122"/>
+                <a:cs typeface="Calibri" pitchFamily="34" charset="-120"/>
+              </a:rPr>
+              <a:t>.</a:t>
             </a:r>
             <a:endParaRPr lang="en-US" sz="1150" dirty="0"/>
           </a:p>
@@ -13972,6 +11998,84 @@
               <a:t>08</a:t>
             </a:r>
             <a:endParaRPr lang="en-US" sz="1000" dirty="0"/>
+          </a:p>
+        </p:txBody>
+      </p:sp>
+      <p:sp>
+        <p:nvSpPr>
+          <p:cNvPr id="39" name="Shape 28">
+            <a:extLst>
+              <a:ext uri="{FF2B5EF4-FFF2-40B4-BE49-F238E27FC236}">
+                <a16:creationId xmlns:a16="http://schemas.microsoft.com/office/drawing/2014/main" id="{923FC58C-86E9-291B-0885-B7DDAA4EBA6B}"/>
+              </a:ext>
+            </a:extLst>
+          </p:cNvPr>
+          <p:cNvSpPr/>
+          <p:nvPr/>
+        </p:nvSpPr>
+        <p:spPr>
+          <a:xfrm>
+            <a:off x="6137596" y="4143258"/>
+            <a:ext cx="173736" cy="173736"/>
+          </a:xfrm>
+          <a:prstGeom prst="ellipse">
+            <a:avLst/>
+          </a:prstGeom>
+          <a:solidFill>
+            <a:srgbClr val="D9870B"/>
+          </a:solidFill>
+          <a:ln/>
+        </p:spPr>
+        <p:txBody>
+          <a:bodyPr/>
+          <a:lstStyle/>
+          <a:p>
+            <a:endParaRPr lang="de-AT"/>
+          </a:p>
+        </p:txBody>
+      </p:sp>
+      <p:sp>
+        <p:nvSpPr>
+          <p:cNvPr id="40" name="Text 26">
+            <a:extLst>
+              <a:ext uri="{FF2B5EF4-FFF2-40B4-BE49-F238E27FC236}">
+                <a16:creationId xmlns:a16="http://schemas.microsoft.com/office/drawing/2014/main" id="{D72A3E97-788E-02F9-63C0-1B30064F1711}"/>
+              </a:ext>
+            </a:extLst>
+          </p:cNvPr>
+          <p:cNvSpPr/>
+          <p:nvPr/>
+        </p:nvSpPr>
+        <p:spPr>
+          <a:xfrm>
+            <a:off x="6137596" y="4143258"/>
+            <a:ext cx="173736" cy="173736"/>
+          </a:xfrm>
+          <a:prstGeom prst="rect">
+            <a:avLst/>
+          </a:prstGeom>
+          <a:noFill/>
+          <a:ln/>
+        </p:spPr>
+        <p:txBody>
+          <a:bodyPr wrap="square" lIns="0" tIns="0" rIns="0" bIns="0" rtlCol="0" anchor="ctr"/>
+          <a:lstStyle/>
+          <a:p>
+            <a:pPr marL="0" indent="0" algn="ctr">
+              <a:buNone/>
+            </a:pPr>
+            <a:r>
+              <a:rPr lang="en-US" sz="950" b="1" dirty="0">
+                <a:solidFill>
+                  <a:srgbClr val="FFFFFF"/>
+                </a:solidFill>
+                <a:latin typeface="Calibri" pitchFamily="34" charset="0"/>
+                <a:ea typeface="Calibri" pitchFamily="34" charset="-122"/>
+                <a:cs typeface="Calibri" pitchFamily="34" charset="-120"/>
+              </a:rPr>
+              <a:t>!</a:t>
+            </a:r>
+            <a:endParaRPr lang="en-US" sz="950" dirty="0"/>
           </a:p>
         </p:txBody>
       </p:sp>
@@ -14326,7 +12430,7 @@
           <a:bodyPr/>
           <a:lstStyle/>
           <a:p>
-            <a:endParaRPr lang="de-AT"/>
+            <a:endParaRPr lang="de-AT" dirty="0"/>
           </a:p>
         </p:txBody>
       </p:sp>
@@ -14363,7 +12467,7 @@
                 <a:ea typeface="Courier New" pitchFamily="34" charset="-122"/>
                 <a:cs typeface="Courier New" pitchFamily="34" charset="-120"/>
               </a:rPr>
-              <a:t>4 GETESTETE USER-JOURNEYS</a:t>
+              <a:t>4 Tests</a:t>
             </a:r>
             <a:endParaRPr lang="en-US" sz="1000" dirty="0"/>
           </a:p>
@@ -14787,6 +12891,17 @@
               <a:buNone/>
             </a:pPr>
             <a:r>
+              <a:rPr lang="en-US" sz="1100" dirty="0" err="1">
+                <a:solidFill>
+                  <a:srgbClr val="12181F"/>
+                </a:solidFill>
+                <a:latin typeface="Calibri" pitchFamily="34" charset="0"/>
+                <a:ea typeface="Calibri" pitchFamily="34" charset="-122"/>
+                <a:cs typeface="Calibri" pitchFamily="34" charset="-120"/>
+              </a:rPr>
+              <a:t>Mehrmaliges</a:t>
+            </a:r>
+            <a:r>
               <a:rPr lang="en-US" sz="1100" dirty="0">
                 <a:solidFill>
                   <a:srgbClr val="12181F"/>
@@ -14795,7 +12910,62 @@
                 <a:ea typeface="Calibri" pitchFamily="34" charset="-122"/>
                 <a:cs typeface="Calibri" pitchFamily="34" charset="-120"/>
               </a:rPr>
-              <a:t>Navigation bei leerem Warenkorb</a:t>
+              <a:t> </a:t>
+            </a:r>
+            <a:r>
+              <a:rPr lang="en-US" sz="1100" dirty="0" err="1">
+                <a:solidFill>
+                  <a:srgbClr val="12181F"/>
+                </a:solidFill>
+                <a:latin typeface="Calibri" pitchFamily="34" charset="0"/>
+                <a:ea typeface="Calibri" pitchFamily="34" charset="-122"/>
+                <a:cs typeface="Calibri" pitchFamily="34" charset="-120"/>
+              </a:rPr>
+              <a:t>Hinzufügen</a:t>
+            </a:r>
+            <a:r>
+              <a:rPr lang="en-US" sz="1100" dirty="0">
+                <a:solidFill>
+                  <a:srgbClr val="12181F"/>
+                </a:solidFill>
+                <a:latin typeface="Calibri" pitchFamily="34" charset="0"/>
+                <a:ea typeface="Calibri" pitchFamily="34" charset="-122"/>
+                <a:cs typeface="Calibri" pitchFamily="34" charset="-120"/>
+              </a:rPr>
+              <a:t> </a:t>
+            </a:r>
+            <a:r>
+              <a:rPr lang="en-US" sz="1100" dirty="0" err="1">
+                <a:solidFill>
+                  <a:srgbClr val="12181F"/>
+                </a:solidFill>
+                <a:latin typeface="Calibri" pitchFamily="34" charset="0"/>
+                <a:ea typeface="Calibri" pitchFamily="34" charset="-122"/>
+                <a:cs typeface="Calibri" pitchFamily="34" charset="-120"/>
+              </a:rPr>
+              <a:t>eines</a:t>
+            </a:r>
+            <a:r>
+              <a:rPr lang="en-US" sz="1100" dirty="0">
+                <a:solidFill>
+                  <a:srgbClr val="12181F"/>
+                </a:solidFill>
+                <a:latin typeface="Calibri" pitchFamily="34" charset="0"/>
+                <a:ea typeface="Calibri" pitchFamily="34" charset="-122"/>
+                <a:cs typeface="Calibri" pitchFamily="34" charset="-120"/>
+              </a:rPr>
+              <a:t> </a:t>
+            </a:r>
+            <a:r>
+              <a:rPr lang="en-US" sz="1100" dirty="0" err="1">
+                <a:solidFill>
+                  <a:srgbClr val="12181F"/>
+                </a:solidFill>
+                <a:latin typeface="Calibri" pitchFamily="34" charset="0"/>
+                <a:ea typeface="Calibri" pitchFamily="34" charset="-122"/>
+                <a:cs typeface="Calibri" pitchFamily="34" charset="-120"/>
+              </a:rPr>
+              <a:t>Produkts</a:t>
             </a:r>
             <a:endParaRPr lang="en-US" sz="1100" dirty="0"/>
           </a:p>
@@ -15963,7 +14133,51 @@
                 <a:ea typeface="Calibri" pitchFamily="34" charset="-122"/>
                 <a:cs typeface="Calibri" pitchFamily="34" charset="-120"/>
               </a:rPr>
-              <a:t>der Reload-Test beweist, dass die Server-Session den Warenkorb hält – alle 4 grün.</a:t>
+              <a:t>der Reload-Test beweist, dass die Server-Session den </a:t>
+            </a:r>
+            <a:r>
+              <a:rPr lang="en-US" sz="1100" dirty="0" err="1">
+                <a:solidFill>
+                  <a:srgbClr val="12181F"/>
+                </a:solidFill>
+                <a:latin typeface="Calibri" pitchFamily="34" charset="0"/>
+                <a:ea typeface="Calibri" pitchFamily="34" charset="-122"/>
+                <a:cs typeface="Calibri" pitchFamily="34" charset="-120"/>
+              </a:rPr>
+              <a:t>Warenkorb</a:t>
+            </a:r>
+            <a:r>
+              <a:rPr lang="en-US" sz="1100" dirty="0">
+                <a:solidFill>
+                  <a:srgbClr val="12181F"/>
+                </a:solidFill>
+                <a:latin typeface="Calibri" pitchFamily="34" charset="0"/>
+                <a:ea typeface="Calibri" pitchFamily="34" charset="-122"/>
+                <a:cs typeface="Calibri" pitchFamily="34" charset="-120"/>
+              </a:rPr>
+              <a:t> </a:t>
+            </a:r>
+            <a:r>
+              <a:rPr lang="en-US" sz="1100" dirty="0" err="1">
+                <a:solidFill>
+                  <a:srgbClr val="12181F"/>
+                </a:solidFill>
+                <a:latin typeface="Calibri" pitchFamily="34" charset="0"/>
+                <a:ea typeface="Calibri" pitchFamily="34" charset="-122"/>
+                <a:cs typeface="Calibri" pitchFamily="34" charset="-120"/>
+              </a:rPr>
+              <a:t>hält</a:t>
+            </a:r>
+            <a:r>
+              <a:rPr lang="en-US" sz="1100" dirty="0">
+                <a:solidFill>
+                  <a:srgbClr val="12181F"/>
+                </a:solidFill>
+                <a:latin typeface="Calibri" pitchFamily="34" charset="0"/>
+                <a:ea typeface="Calibri" pitchFamily="34" charset="-122"/>
+                <a:cs typeface="Calibri" pitchFamily="34" charset="-120"/>
+              </a:rPr>
+              <a:t>.</a:t>
             </a:r>
             <a:endParaRPr lang="en-US" sz="1100" dirty="0"/>
           </a:p>
@@ -17330,56 +15544,6 @@
                 <a:cs typeface="Calibri" pitchFamily="34" charset="-120"/>
               </a:rPr>
               <a:t>95 % der Anfragen sind schneller als dieser Wert – ehrlicher als der Durchschnitt, der Ausreißer versteckt.</a:t>
-            </a:r>
-            <a:endParaRPr lang="en-US" sz="1100" dirty="0"/>
-          </a:p>
-        </p:txBody>
-      </p:sp>
-      <p:sp>
-        <p:nvSpPr>
-          <p:cNvPr id="22" name="Text 20"/>
-          <p:cNvSpPr/>
-          <p:nvPr/>
-        </p:nvSpPr>
-        <p:spPr>
-          <a:xfrm>
-            <a:off x="5120640" y="4279392"/>
-            <a:ext cx="3474720" cy="320040"/>
-          </a:xfrm>
-          <a:prstGeom prst="rect">
-            <a:avLst/>
-          </a:prstGeom>
-          <a:noFill/>
-          <a:ln/>
-        </p:spPr>
-        <p:txBody>
-          <a:bodyPr wrap="square" lIns="0" tIns="0" rIns="0" bIns="0" rtlCol="0" anchor="ctr"/>
-          <a:lstStyle/>
-          <a:p>
-            <a:pPr marL="0" indent="0">
-              <a:buNone/>
-            </a:pPr>
-            <a:r>
-              <a:rPr lang="en-US" sz="1100" dirty="0">
-                <a:solidFill>
-                  <a:srgbClr val="06B6D4"/>
-                </a:solidFill>
-                <a:latin typeface="Courier New" pitchFamily="34" charset="0"/>
-                <a:ea typeface="Courier New" pitchFamily="34" charset="-122"/>
-                <a:cs typeface="Courier New" pitchFamily="34" charset="-120"/>
-              </a:rPr>
-              <a:t>Ziel-SLO:  </a:t>
-            </a:r>
-            <a:r>
-              <a:rPr lang="en-US" sz="1500" b="1" dirty="0">
-                <a:solidFill>
-                  <a:srgbClr val="FFFFFF"/>
-                </a:solidFill>
-                <a:latin typeface="Calibri" pitchFamily="34" charset="0"/>
-                <a:ea typeface="Calibri" pitchFamily="34" charset="-122"/>
-                <a:cs typeface="Calibri" pitchFamily="34" charset="-120"/>
-              </a:rPr>
-              <a:t>p95 &lt; 500 ms</a:t>
             </a:r>
             <a:endParaRPr lang="en-US" sz="1100" dirty="0"/>
           </a:p>

</xml_diff>

<commit_message>
minor changes integration test in ppt and comment in integration tests
</commit_message>
<xml_diff>
--- a/PRESENTATION.pptx
+++ b/PRESENTATION.pptx
@@ -10982,7 +10982,7 @@
                 <a:ea typeface="Calibri" pitchFamily="34" charset="-122"/>
                 <a:cs typeface="Calibri" pitchFamily="34" charset="-120"/>
               </a:rPr>
-              <a:t>GET /cart redirect </a:t>
+              <a:t>GET /cart </a:t>
             </a:r>
             <a:r>
               <a:rPr lang="en-US" sz="1100" dirty="0" err="1">
@@ -10993,7 +10993,7 @@
                 <a:ea typeface="Calibri" pitchFamily="34" charset="-122"/>
                 <a:cs typeface="Calibri" pitchFamily="34" charset="-120"/>
               </a:rPr>
-              <a:t>zu</a:t>
+              <a:t>Warenkorb</a:t>
             </a:r>
             <a:r>
               <a:rPr lang="en-US" sz="1100" dirty="0">
@@ -11004,18 +11004,7 @@
                 <a:ea typeface="Calibri" pitchFamily="34" charset="-122"/>
                 <a:cs typeface="Calibri" pitchFamily="34" charset="-120"/>
               </a:rPr>
-              <a:t> </a:t>
-            </a:r>
-            <a:r>
-              <a:rPr lang="en-US" sz="1100" dirty="0" err="1">
-                <a:solidFill>
-                  <a:srgbClr val="12181F"/>
-                </a:solidFill>
-                <a:latin typeface="Calibri" pitchFamily="34" charset="0"/>
-                <a:ea typeface="Calibri" pitchFamily="34" charset="-122"/>
-                <a:cs typeface="Calibri" pitchFamily="34" charset="-120"/>
-              </a:rPr>
-              <a:t>Warenkorb</a:t>
+              <a:t> initial leer</a:t>
             </a:r>
             <a:endParaRPr lang="en-US" sz="1100" dirty="0"/>
           </a:p>
@@ -11419,7 +11408,7 @@
                 <a:ea typeface="Calibri" pitchFamily="34" charset="-122"/>
                 <a:cs typeface="Calibri" pitchFamily="34" charset="-120"/>
               </a:rPr>
-              <a:t>/add → 302 Redirect + set-cookie</a:t>
+              <a:t>/add → 302 Redirect</a:t>
             </a:r>
             <a:endParaRPr lang="en-US" sz="1100" dirty="0"/>
           </a:p>

</xml_diff>